<commit_message>
Guión y Entregables H1
</commit_message>
<xml_diff>
--- a/02-PROFESORADO/03-PRESENTACIONES/POR-SESION/h1/S206-presentar-h1-y-delimitar-alcance-presentacion.pptx
+++ b/02-PROFESORADO/03-PRESENTACIONES/POR-SESION/h1/S206-presentar-h1-y-delimitar-alcance-presentacion.pptx
@@ -650,7 +650,7 @@
           </a:p>
           <a:p>
             <a:r>
-              <a:t>Diapositiva 2 de 9: Qué debe conseguirse</a:t>
+              <a:t>Diapositiva 2 de 9: Qué aprenderás y cómo lo demostrarás</a:t>
             </a:r>
           </a:p>
           <a:p>
@@ -665,7 +665,7 @@
           </a:p>
           <a:p>
             <a:r>
-              <a:t>- Al terminar: señala la evidencia, explica qué demuestra y reproduce la prueba.</a:t>
+              <a:t>- Comprobación: Quede una evidencia y siguiente paso registrados.</a:t>
             </a:r>
           </a:p>
           <a:p>
@@ -745,7 +745,7 @@
           </a:p>
           <a:p>
             <a:r>
-              <a:t>Diapositiva 3 de 9: Ejemplo o demostración · 1</a:t>
+              <a:t>Diapositiva 3 de 9: H1 ahora; lo demás después</a:t>
             </a:r>
           </a:p>
           <a:p>
@@ -755,32 +755,22 @@
           </a:p>
           <a:p>
             <a:r>
-              <a:t>Modela el ejemplo sin resolver la actividad completa; pide una predicción antes de ejecutar.</a:t>
-            </a:r>
-          </a:p>
-          <a:p>
-            <a:r>
-              <a:t>- D1 · ¿Cuál es el MiniJarvis más pequeño que ya podemos demostrar? — Un programa Java de consola pequeño, ejecutable y defendible.</a:t>
-            </a:r>
-          </a:p>
-          <a:p>
-            <a:r>
-              <a:t>- Todavía NO buscamos una IA completa.</a:t>
-            </a:r>
-          </a:p>
-          <a:p>
-            <a:r>
-              <a:t>- D2 · Mira primero el resultado — Una salida posible. No es la única solución.</a:t>
-            </a:r>
-          </a:p>
-          <a:p>
-            <a:r>
-              <a:t>- Hola, soy MiniJarvis.</a:t>
-            </a:r>
-          </a:p>
-          <a:p>
-            <a:r>
-              <a:t>- ¿Cómo te llamas? Laura</a:t>
+              <a:t>Explica con predicción y ejemplo mínimo; comprueba comprensión antes de continuar.</a:t>
+            </a:r>
+          </a:p>
+          <a:p>
+            <a:r>
+              <a:t>- AHORA · programa Java de consola, saludo, datos simples, entrada/salida, prueba y explicación</a:t>
+            </a:r>
+          </a:p>
+          <a:p>
+            <a:r>
+              <a:t>- DESPUÉS O FUERA · menús, bucles, memoria persistente, ficheros, credenciales e IA real</a:t>
+            </a:r>
+          </a:p>
+          <a:p>
+            <a:r>
+              <a:t>- Una función entra en H1 solo si puede observarse, probarse y defenderse sin inflar el producto.</a:t>
             </a:r>
           </a:p>
           <a:p>
@@ -860,7 +850,7 @@
           </a:p>
           <a:p>
             <a:r>
-              <a:t>Diapositiva 4 de 9: Ejemplo o demostración · 2</a:t>
+              <a:t>Diapositiva 4 de 9: El MiniJarvis mínimo ya es demostrable</a:t>
             </a:r>
           </a:p>
           <a:p>
@@ -870,27 +860,32 @@
           </a:p>
           <a:p>
             <a:r>
-              <a:t>Modela el ejemplo sin resolver la actividad completa; pide una predicción antes de ejecutar.</a:t>
-            </a:r>
-          </a:p>
-          <a:p>
-            <a:r>
-              <a:t>- Encantado, Laura.</a:t>
-            </a:r>
-          </a:p>
-          <a:p>
-            <a:r>
-              <a:t>- Estoy aprendiendo la base de Java.</a:t>
-            </a:r>
-          </a:p>
-          <a:p>
-            <a:r>
-              <a:t>- D3 · ¿Qué hace bueno a un primer programa? CORRECTO: Hace la tarea pedida y podemos comprobarlo. \| EFICIENTE: No añade trabajo o complejidad que no necesita.</a:t>
-            </a:r>
-          </a:p>
-          <a:p>
-            <a:r>
-              <a:t>- \| MANTENIBLE: Se entiende y puede modificarse sin romperlo.</a:t>
+              <a:t>Explica con predicción y ejemplo mínimo; comprueba comprensión antes de continuar.</a:t>
+            </a:r>
+          </a:p>
+          <a:p>
+            <a:r>
+              <a:t>- Hola, soy MiniJarvis.</a:t>
+            </a:r>
+          </a:p>
+          <a:p>
+            <a:r>
+              <a:t>¿Cómo te llamas? Laura</a:t>
+            </a:r>
+          </a:p>
+          <a:p>
+            <a:r>
+              <a:t>Encantado, Laura.</a:t>
+            </a:r>
+          </a:p>
+          <a:p>
+            <a:r>
+              <a:t>Estoy aprendiendo la base de Java.</a:t>
+            </a:r>
+          </a:p>
+          <a:p>
+            <a:r>
+              <a:t>- Describe exactamente lo que existe: no promete memoria ni inteligencia que todavía no tiene.</a:t>
             </a:r>
           </a:p>
           <a:p>
@@ -970,7 +965,7 @@
           </a:p>
           <a:p>
             <a:r>
-              <a:t>Diapositiva 5 de 9: Actividad central · 1</a:t>
+              <a:t>Diapositiva 5 de 9: De una idea a requisitos comprobables</a:t>
             </a:r>
           </a:p>
           <a:p>
@@ -980,27 +975,27 @@
           </a:p>
           <a:p>
             <a:r>
-              <a:t>Entrega la consigna, observa decisiones y pide una prueba reproducible.</a:t>
-            </a:r>
-          </a:p>
-          <a:p>
-            <a:r>
-              <a:t>- Predice antes de ejecutar cuando haya código.</a:t>
-            </a:r>
-          </a:p>
-          <a:p>
-            <a:r>
-              <a:t>- Realiza la micropráctica o modificación prevista.</a:t>
-            </a:r>
-          </a:p>
-          <a:p>
-            <a:r>
-              <a:t>- Prueba el caso normal y, cuando exista una decisión o conversión, también el caso alternativo o erróneo.</a:t>
-            </a:r>
-          </a:p>
-          <a:p>
-            <a:r>
-              <a:t>- Conserva el código o resultado en el repositorio o espacio indicado.</a:t>
+              <a:t>Explica con predicción y ejemplo mínimo; comprueba comprensión antes de continuar.</a:t>
+            </a:r>
+          </a:p>
+          <a:p>
+            <a:r>
+              <a:t>- Muestra · pide · guarda · calcula · ejecuta · explica: verbos que producen resultados observables.</a:t>
+            </a:r>
+          </a:p>
+          <a:p>
+            <a:r>
+              <a:t>- Correcto: cumple la tarea y supera los casos previstos.</a:t>
+            </a:r>
+          </a:p>
+          <a:p>
+            <a:r>
+              <a:t>- Sencillo: no añade trabajo o complejidad innecesaria.</a:t>
+            </a:r>
+          </a:p>
+          <a:p>
+            <a:r>
+              <a:t>- Mantenible: se entiende y puede modificarse sin romperse.</a:t>
             </a:r>
           </a:p>
           <a:p>
@@ -1080,7 +1075,7 @@
           </a:p>
           <a:p>
             <a:r>
-              <a:t>Diapositiva 6 de 9: Actividad central · 2</a:t>
+              <a:t>Diapositiva 6 de 9: Delimita el incremento H1</a:t>
             </a:r>
           </a:p>
           <a:p>
@@ -1095,12 +1090,22 @@
           </a:p>
           <a:p>
             <a:r>
-              <a:t>- Registra una sola entrada en el diario individual; no crees un informe paralelo.</a:t>
-            </a:r>
-          </a:p>
-          <a:p>
-            <a:r>
-              <a:t>- ¿Qué puedes señalar, explicar y probar al terminar este checkpoint?</a:t>
+              <a:t>- Clasifica cada propuesta en H1 ahora, hito posterior o fuera del reto.</a:t>
+            </a:r>
+          </a:p>
+          <a:p>
+            <a:r>
+              <a:t>- Escribe entre 4 y 6 requisitos observables.</a:t>
+            </a:r>
+          </a:p>
+          <a:p>
+            <a:r>
+              <a:t>- Añade 2 o 3 límites explícitos.</a:t>
+            </a:r>
+          </a:p>
+          <a:p>
+            <a:r>
+              <a:t>- Para cada requisito indica cómo lo comprobarás.</a:t>
             </a:r>
           </a:p>
           <a:p>
@@ -1180,7 +1185,7 @@
           </a:p>
           <a:p>
             <a:r>
-              <a:t>Diapositiva 7 de 9: Evidencia y comprobación</a:t>
+              <a:t>Diapositiva 7 de 9: Puerta de avance</a:t>
             </a:r>
           </a:p>
           <a:p>
@@ -1195,17 +1200,22 @@
           </a:p>
           <a:p>
             <a:r>
-              <a:t>- conserva el código o la prueba en el lugar indicado por la sesión;</a:t>
-            </a:r>
-          </a:p>
-          <a:p>
-            <a:r>
-              <a:t>- añade una sola entrada al diario individual con prueba, bloqueo y siguiente paso;</a:t>
-            </a:r>
-          </a:p>
-          <a:p>
-            <a:r>
-              <a:t>- no copies la misma reflexión en otro documento; el Site personal seleccionará evidencias al cerrar H1.</a:t>
+              <a:t>- Puedo describir H1 en una frase.</a:t>
+            </a:r>
+          </a:p>
+          <a:p>
+            <a:r>
+              <a:t>- Cada requisito tiene una prueba observable.</a:t>
+            </a:r>
+          </a:p>
+          <a:p>
+            <a:r>
+              <a:t>- Puedo justificar por qué una función queda fuera.</a:t>
+            </a:r>
+          </a:p>
+          <a:p>
+            <a:r>
+              <a:t>- He definido una evidencia concreta y el siguiente paso.</a:t>
             </a:r>
           </a:p>
           <a:p>
@@ -1285,7 +1295,7 @@
           </a:p>
           <a:p>
             <a:r>
-              <a:t>Diapositiva 8 de 9: Seguridad y uso responsable</a:t>
+              <a:t>Diapositiva 8 de 9: Defiende el alcance</a:t>
             </a:r>
           </a:p>
           <a:p>
@@ -1295,17 +1305,12 @@
           </a:p>
           <a:p>
             <a:r>
-              <a:t>Recuerda estos límites antes de que el alumnado comparta o publique:</a:t>
-            </a:r>
-          </a:p>
-          <a:p>
-            <a:r>
-              <a:t>- Usa datos ficticios y no publiques credenciales ni información personal.</a:t>
-            </a:r>
-          </a:p>
-          <a:p>
-            <a:r>
-              <a:t>- Si utilizas IA de forma sustantiva, registra propósito, propuesta, cambios propios y validación en el registro de IA del hito.</a:t>
+              <a:t>Cierra con explicación individual, prueba observable y siguiente paso concreto.</a:t>
+            </a:r>
+          </a:p>
+          <a:p>
+            <a:r>
+              <a:t>- Completa: H1 no tendrá ____ porque ____; lo comprobaremos mediante ____. </a:t>
             </a:r>
           </a:p>
           <a:p>
@@ -1385,7 +1390,7 @@
           </a:p>
           <a:p>
             <a:r>
-              <a:t>Diapositiva 9 de 9: Cierre y defensa</a:t>
+              <a:t>Diapositiva 9 de 9: Fuentes utilizadas</a:t>
             </a:r>
           </a:p>
           <a:p>
@@ -1395,12 +1400,22 @@
           </a:p>
           <a:p>
             <a:r>
-              <a:t>Cierra con explicación individual, prueba observable y siguiente paso concreto.</a:t>
-            </a:r>
-          </a:p>
-          <a:p>
-            <a:r>
-              <a:t>- ¿Qué puedes señalar, explicar y probar al terminar este checkpoint?</a:t>
+              <a:t>Indica al alumnado dónde ampliar el contenido y qué fragmentos se han adaptado.</a:t>
+            </a:r>
+          </a:p>
+          <a:p>
+            <a:r>
+              <a:t>- Libro: introducción de H1 · Tema 1: objetivos de un programa</a:t>
+            </a:r>
+          </a:p>
+          <a:p>
+            <a:r>
+              <a:t>- Fichas S206-S215 y píldoras H1</a:t>
+            </a:r>
+          </a:p>
+          <a:p>
+            <a:r>
+              <a:t>- Ejemplos revisados y adaptados a MiniJarvis; no se copian errores ni capturas antiguas del PDF.</a:t>
             </a:r>
           </a:p>
           <a:p>
@@ -4645,7 +4660,7 @@
               </a:defRPr>
             </a:pPr>
             <a:r>
-              <a:t>H1 — Primer MiniJarvis · Fase HEXA: Activar — entender el reto</a:t>
+              <a:t>H1 — Primer MiniJarvis</a:t>
             </a:r>
           </a:p>
         </p:txBody>
@@ -4929,7 +4944,7 @@
               </a:defRPr>
             </a:pPr>
             <a:r>
-              <a:t>Qué debe conseguirse</a:t>
+              <a:t>Qué aprenderás y cómo lo demostrarás</a:t>
             </a:r>
           </a:p>
         </p:txBody>
@@ -5170,7 +5185,7 @@
               </a:defRPr>
             </a:pPr>
             <a:r>
-              <a:t>Al terminar: señala la evidencia, explica qué demuestra y reproduce la prueba.</a:t>
+              <a:t>Comprobación: Quede una evidencia y siguiente paso registrados.</a:t>
             </a:r>
           </a:p>
         </p:txBody>
@@ -5310,7 +5325,7 @@
               </a:defRPr>
             </a:pPr>
             <a:r>
-              <a:t>OBSERVAR ANTES DE ACTUAR</a:t>
+              <a:t>CONTRASTAR PARA DECIDIR</a:t>
             </a:r>
           </a:p>
         </p:txBody>
@@ -5346,7 +5361,7 @@
               </a:defRPr>
             </a:pPr>
             <a:r>
-              <a:t>Ejemplo o demostración · 1</a:t>
+              <a:t>H1 ahora; lo demás después</a:t>
             </a:r>
           </a:p>
         </p:txBody>
@@ -5438,17 +5453,19 @@
         </p:nvSpPr>
         <p:spPr>
           <a:xfrm>
-            <a:off x="621792" y="1353312"/>
-            <a:ext cx="10927080" cy="4526280"/>
+            <a:off x="621792" y="1325880"/>
+            <a:ext cx="5230368" cy="3401568"/>
           </a:xfrm>
           <a:prstGeom prst="roundRect">
             <a:avLst/>
           </a:prstGeom>
           <a:solidFill>
-            <a:srgbClr val="121824"/>
+            <a:srgbClr val="FFFFFF"/>
           </a:solidFill>
           <a:ln>
-            <a:noFill/>
+            <a:solidFill>
+              <a:srgbClr val="445B80"/>
+            </a:solidFill>
           </a:ln>
         </p:spPr>
         <p:style>
@@ -5475,14 +5492,59 @@
       </p:sp>
       <p:sp>
         <p:nvSpPr>
-          <p:cNvPr id="9" name="TextBox 8"/>
+          <p:cNvPr id="9" name="Rounded Rectangle 8"/>
+          <p:cNvSpPr/>
+          <p:nvPr/>
+        </p:nvSpPr>
+        <p:spPr>
+          <a:xfrm>
+            <a:off x="850392" y="1572768"/>
+            <a:ext cx="566928" cy="475488"/>
+          </a:xfrm>
+          <a:prstGeom prst="roundRect">
+            <a:avLst/>
+          </a:prstGeom>
+          <a:solidFill>
+            <a:srgbClr val="445B80"/>
+          </a:solidFill>
+          <a:ln>
+            <a:solidFill>
+              <a:srgbClr val="445B80"/>
+            </a:solidFill>
+          </a:ln>
+        </p:spPr>
+        <p:style>
+          <a:lnRef idx="1">
+            <a:schemeClr val="accent1"/>
+          </a:lnRef>
+          <a:fillRef idx="3">
+            <a:schemeClr val="accent1"/>
+          </a:fillRef>
+          <a:effectRef idx="2">
+            <a:schemeClr val="accent1"/>
+          </a:effectRef>
+          <a:fontRef idx="minor">
+            <a:schemeClr val="lt1"/>
+          </a:fontRef>
+        </p:style>
+        <p:txBody>
+          <a:bodyPr rtlCol="0" anchor="ctr"/>
+          <a:lstStyle/>
+          <a:p>
+            <a:pPr algn="ctr"/>
+          </a:p>
+        </p:txBody>
+      </p:sp>
+      <p:sp>
+        <p:nvSpPr>
+          <p:cNvPr id="10" name="TextBox 9"/>
           <p:cNvSpPr txBox="1"/>
           <p:nvPr/>
         </p:nvSpPr>
         <p:spPr>
           <a:xfrm>
-            <a:off x="932688" y="1627632"/>
-            <a:ext cx="2057400" cy="411480"/>
+            <a:off x="850392" y="1682496"/>
+            <a:ext cx="566928" cy="182880"/>
           </a:xfrm>
           <a:prstGeom prst="rect">
             <a:avLst/>
@@ -5495,47 +5557,8 @@
           </a:bodyPr>
           <a:lstStyle/>
           <a:p>
-            <a:pPr algn="l">
+            <a:pPr algn="ctr">
               <a:defRPr sz="1300" b="1">
-                <a:solidFill>
-                  <a:srgbClr val="2F5BA8"/>
-                </a:solidFill>
-                <a:latin typeface="Aptos"/>
-              </a:defRPr>
-            </a:pPr>
-            <a:r>
-              <a:t>DEMOSTRACIÓN</a:t>
-            </a:r>
-          </a:p>
-        </p:txBody>
-      </p:sp>
-      <p:sp>
-        <p:nvSpPr>
-          <p:cNvPr id="10" name="TextBox 9"/>
-          <p:cNvSpPr txBox="1"/>
-          <p:nvPr/>
-        </p:nvSpPr>
-        <p:spPr>
-          <a:xfrm>
-            <a:off x="932688" y="2212848"/>
-            <a:ext cx="9966960" cy="3246120"/>
-          </a:xfrm>
-          <a:prstGeom prst="rect">
-            <a:avLst/>
-          </a:prstGeom>
-          <a:noFill/>
-        </p:spPr>
-        <p:txBody>
-          <a:bodyPr wrap="square" lIns="73152" rIns="45720" tIns="36576">
-            <a:spAutoFit/>
-          </a:bodyPr>
-          <a:lstStyle/>
-          <a:p>
-            <a:pPr>
-              <a:spcAft>
-                <a:spcPts val="900"/>
-              </a:spcAft>
-              <a:defRPr sz="2200">
                 <a:solidFill>
                   <a:srgbClr val="FFFFFF"/>
                 </a:solidFill>
@@ -5543,15 +5566,161 @@
               </a:defRPr>
             </a:pPr>
             <a:r>
-              <a:t>•  D1 · ¿Cuál es el MiniJarvis más pequeño que ya podemos demostrar? — Un programa Java de consola pequeño, ejecutable y defendible.</a:t>
-            </a:r>
-          </a:p>
-          <a:p>
-            <a:pPr>
-              <a:spcAft>
-                <a:spcPts val="900"/>
-              </a:spcAft>
-              <a:defRPr sz="2200">
+              <a:t>A</a:t>
+            </a:r>
+          </a:p>
+        </p:txBody>
+      </p:sp>
+      <p:sp>
+        <p:nvSpPr>
+          <p:cNvPr id="11" name="TextBox 10"/>
+          <p:cNvSpPr txBox="1"/>
+          <p:nvPr/>
+        </p:nvSpPr>
+        <p:spPr>
+          <a:xfrm>
+            <a:off x="896112" y="2267712"/>
+            <a:ext cx="4663440" cy="2057400"/>
+          </a:xfrm>
+          <a:prstGeom prst="rect">
+            <a:avLst/>
+          </a:prstGeom>
+          <a:noFill/>
+        </p:spPr>
+        <p:txBody>
+          <a:bodyPr wrap="square" lIns="45720" rIns="45720" tIns="36576" bIns="36576" anchor="t">
+            <a:spAutoFit/>
+          </a:bodyPr>
+          <a:lstStyle/>
+          <a:p>
+            <a:pPr algn="l">
+              <a:defRPr sz="2100" b="1">
+                <a:solidFill>
+                  <a:srgbClr val="1C2330"/>
+                </a:solidFill>
+                <a:latin typeface="Aptos"/>
+              </a:defRPr>
+            </a:pPr>
+            <a:r>
+              <a:t>AHORA · programa Java de consola, saludo, datos simples, entrada/salida, prueba y explicación</a:t>
+            </a:r>
+          </a:p>
+        </p:txBody>
+      </p:sp>
+      <p:sp>
+        <p:nvSpPr>
+          <p:cNvPr id="12" name="Rounded Rectangle 11"/>
+          <p:cNvSpPr/>
+          <p:nvPr/>
+        </p:nvSpPr>
+        <p:spPr>
+          <a:xfrm>
+            <a:off x="6153912" y="1325880"/>
+            <a:ext cx="5230368" cy="3401568"/>
+          </a:xfrm>
+          <a:prstGeom prst="roundRect">
+            <a:avLst/>
+          </a:prstGeom>
+          <a:solidFill>
+            <a:srgbClr val="FFFFFF"/>
+          </a:solidFill>
+          <a:ln>
+            <a:solidFill>
+              <a:srgbClr val="2F5BA8"/>
+            </a:solidFill>
+          </a:ln>
+        </p:spPr>
+        <p:style>
+          <a:lnRef idx="1">
+            <a:schemeClr val="accent1"/>
+          </a:lnRef>
+          <a:fillRef idx="3">
+            <a:schemeClr val="accent1"/>
+          </a:fillRef>
+          <a:effectRef idx="2">
+            <a:schemeClr val="accent1"/>
+          </a:effectRef>
+          <a:fontRef idx="minor">
+            <a:schemeClr val="lt1"/>
+          </a:fontRef>
+        </p:style>
+        <p:txBody>
+          <a:bodyPr rtlCol="0" anchor="ctr"/>
+          <a:lstStyle/>
+          <a:p>
+            <a:pPr algn="ctr"/>
+          </a:p>
+        </p:txBody>
+      </p:sp>
+      <p:sp>
+        <p:nvSpPr>
+          <p:cNvPr id="13" name="Rounded Rectangle 12"/>
+          <p:cNvSpPr/>
+          <p:nvPr/>
+        </p:nvSpPr>
+        <p:spPr>
+          <a:xfrm>
+            <a:off x="6382512" y="1572768"/>
+            <a:ext cx="566928" cy="475488"/>
+          </a:xfrm>
+          <a:prstGeom prst="roundRect">
+            <a:avLst/>
+          </a:prstGeom>
+          <a:solidFill>
+            <a:srgbClr val="2F5BA8"/>
+          </a:solidFill>
+          <a:ln>
+            <a:solidFill>
+              <a:srgbClr val="2F5BA8"/>
+            </a:solidFill>
+          </a:ln>
+        </p:spPr>
+        <p:style>
+          <a:lnRef idx="1">
+            <a:schemeClr val="accent1"/>
+          </a:lnRef>
+          <a:fillRef idx="3">
+            <a:schemeClr val="accent1"/>
+          </a:fillRef>
+          <a:effectRef idx="2">
+            <a:schemeClr val="accent1"/>
+          </a:effectRef>
+          <a:fontRef idx="minor">
+            <a:schemeClr val="lt1"/>
+          </a:fontRef>
+        </p:style>
+        <p:txBody>
+          <a:bodyPr rtlCol="0" anchor="ctr"/>
+          <a:lstStyle/>
+          <a:p>
+            <a:pPr algn="ctr"/>
+          </a:p>
+        </p:txBody>
+      </p:sp>
+      <p:sp>
+        <p:nvSpPr>
+          <p:cNvPr id="14" name="TextBox 13"/>
+          <p:cNvSpPr txBox="1"/>
+          <p:nvPr/>
+        </p:nvSpPr>
+        <p:spPr>
+          <a:xfrm>
+            <a:off x="6382512" y="1682496"/>
+            <a:ext cx="566928" cy="182880"/>
+          </a:xfrm>
+          <a:prstGeom prst="rect">
+            <a:avLst/>
+          </a:prstGeom>
+          <a:noFill/>
+        </p:spPr>
+        <p:txBody>
+          <a:bodyPr wrap="square" lIns="45720" rIns="45720" tIns="36576" bIns="36576" anchor="t">
+            <a:spAutoFit/>
+          </a:bodyPr>
+          <a:lstStyle/>
+          <a:p>
+            <a:pPr algn="ctr">
+              <a:defRPr sz="1300" b="1">
                 <a:solidFill>
                   <a:srgbClr val="FFFFFF"/>
                 </a:solidFill>
@@ -5559,15 +5728,116 @@
               </a:defRPr>
             </a:pPr>
             <a:r>
-              <a:t>•  Todavía NO buscamos una IA completa.</a:t>
-            </a:r>
-          </a:p>
-          <a:p>
-            <a:pPr>
-              <a:spcAft>
-                <a:spcPts val="900"/>
-              </a:spcAft>
-              <a:defRPr sz="2200">
+              <a:t>B</a:t>
+            </a:r>
+          </a:p>
+        </p:txBody>
+      </p:sp>
+      <p:sp>
+        <p:nvSpPr>
+          <p:cNvPr id="15" name="TextBox 14"/>
+          <p:cNvSpPr txBox="1"/>
+          <p:nvPr/>
+        </p:nvSpPr>
+        <p:spPr>
+          <a:xfrm>
+            <a:off x="6428232" y="2267712"/>
+            <a:ext cx="4663440" cy="2057400"/>
+          </a:xfrm>
+          <a:prstGeom prst="rect">
+            <a:avLst/>
+          </a:prstGeom>
+          <a:noFill/>
+        </p:spPr>
+        <p:txBody>
+          <a:bodyPr wrap="square" lIns="45720" rIns="45720" tIns="36576" bIns="36576" anchor="t">
+            <a:spAutoFit/>
+          </a:bodyPr>
+          <a:lstStyle/>
+          <a:p>
+            <a:pPr algn="l">
+              <a:defRPr sz="2100" b="1">
+                <a:solidFill>
+                  <a:srgbClr val="1C2330"/>
+                </a:solidFill>
+                <a:latin typeface="Aptos"/>
+              </a:defRPr>
+            </a:pPr>
+            <a:r>
+              <a:t>DESPUÉS O FUERA · menús, bucles, memoria persistente, ficheros, credenciales e IA real</a:t>
+            </a:r>
+          </a:p>
+        </p:txBody>
+      </p:sp>
+      <p:sp>
+        <p:nvSpPr>
+          <p:cNvPr id="16" name="Rounded Rectangle 15"/>
+          <p:cNvSpPr/>
+          <p:nvPr/>
+        </p:nvSpPr>
+        <p:spPr>
+          <a:xfrm>
+            <a:off x="621792" y="5010912"/>
+            <a:ext cx="10762488" cy="932688"/>
+          </a:xfrm>
+          <a:prstGeom prst="roundRect">
+            <a:avLst/>
+          </a:prstGeom>
+          <a:solidFill>
+            <a:srgbClr val="121824"/>
+          </a:solidFill>
+          <a:ln>
+            <a:solidFill>
+              <a:srgbClr val="121824"/>
+            </a:solidFill>
+          </a:ln>
+        </p:spPr>
+        <p:style>
+          <a:lnRef idx="1">
+            <a:schemeClr val="accent1"/>
+          </a:lnRef>
+          <a:fillRef idx="3">
+            <a:schemeClr val="accent1"/>
+          </a:fillRef>
+          <a:effectRef idx="2">
+            <a:schemeClr val="accent1"/>
+          </a:effectRef>
+          <a:fontRef idx="minor">
+            <a:schemeClr val="lt1"/>
+          </a:fontRef>
+        </p:style>
+        <p:txBody>
+          <a:bodyPr rtlCol="0" anchor="ctr"/>
+          <a:lstStyle/>
+          <a:p>
+            <a:pPr algn="ctr"/>
+          </a:p>
+        </p:txBody>
+      </p:sp>
+      <p:sp>
+        <p:nvSpPr>
+          <p:cNvPr id="17" name="TextBox 16"/>
+          <p:cNvSpPr txBox="1"/>
+          <p:nvPr/>
+        </p:nvSpPr>
+        <p:spPr>
+          <a:xfrm>
+            <a:off x="896112" y="5230368"/>
+            <a:ext cx="10204704" cy="475488"/>
+          </a:xfrm>
+          <a:prstGeom prst="rect">
+            <a:avLst/>
+          </a:prstGeom>
+          <a:noFill/>
+        </p:spPr>
+        <p:txBody>
+          <a:bodyPr wrap="square" lIns="45720" rIns="45720" tIns="36576" bIns="36576" anchor="t">
+            <a:spAutoFit/>
+          </a:bodyPr>
+          <a:lstStyle/>
+          <a:p>
+            <a:pPr algn="ctr">
+              <a:defRPr sz="1700" b="1">
                 <a:solidFill>
                   <a:srgbClr val="FFFFFF"/>
                 </a:solidFill>
@@ -5575,39 +5845,7 @@
               </a:defRPr>
             </a:pPr>
             <a:r>
-              <a:t>•  D2 · Mira primero el resultado — Una salida posible. No es la única solución.</a:t>
-            </a:r>
-          </a:p>
-          <a:p>
-            <a:pPr>
-              <a:spcAft>
-                <a:spcPts val="900"/>
-              </a:spcAft>
-              <a:defRPr sz="2200">
-                <a:solidFill>
-                  <a:srgbClr val="FFFFFF"/>
-                </a:solidFill>
-                <a:latin typeface="Aptos"/>
-              </a:defRPr>
-            </a:pPr>
-            <a:r>
-              <a:t>•  Hola, soy MiniJarvis.</a:t>
-            </a:r>
-          </a:p>
-          <a:p>
-            <a:pPr>
-              <a:spcAft>
-                <a:spcPts val="900"/>
-              </a:spcAft>
-              <a:defRPr sz="2200">
-                <a:solidFill>
-                  <a:srgbClr val="FFFFFF"/>
-                </a:solidFill>
-                <a:latin typeface="Aptos"/>
-              </a:defRPr>
-            </a:pPr>
-            <a:r>
-              <a:t>•  ¿Cómo te llamas? Laura</a:t>
+              <a:t>Una función entra en H1 solo si puede observarse, probarse y defenderse sin inflar el producto.</a:t>
             </a:r>
           </a:p>
         </p:txBody>
@@ -5747,7 +5985,7 @@
               </a:defRPr>
             </a:pPr>
             <a:r>
-              <a:t>OBSERVAR ANTES DE ACTUAR</a:t>
+              <a:t>SALIDA OBSERVABLE</a:t>
             </a:r>
           </a:p>
         </p:txBody>
@@ -5783,7 +6021,7 @@
               </a:defRPr>
             </a:pPr>
             <a:r>
-              <a:t>Ejemplo o demostración · 2</a:t>
+              <a:t>El MiniJarvis mínimo ya es demostrable</a:t>
             </a:r>
           </a:p>
         </p:txBody>
@@ -5875,8 +6113,8 @@
         </p:nvSpPr>
         <p:spPr>
           <a:xfrm>
-            <a:off x="621792" y="1353312"/>
-            <a:ext cx="10927080" cy="4526280"/>
+            <a:off x="658368" y="1371600"/>
+            <a:ext cx="6995160" cy="4526280"/>
           </a:xfrm>
           <a:prstGeom prst="roundRect">
             <a:avLst/>
@@ -5885,7 +6123,9 @@
             <a:srgbClr val="121824"/>
           </a:solidFill>
           <a:ln>
-            <a:noFill/>
+            <a:solidFill>
+              <a:srgbClr val="121824"/>
+            </a:solidFill>
           </a:ln>
         </p:spPr>
         <p:style>
@@ -5918,8 +6158,8 @@
         </p:nvSpPr>
         <p:spPr>
           <a:xfrm>
-            <a:off x="932688" y="1627632"/>
-            <a:ext cx="2057400" cy="411480"/>
+            <a:off x="914400" y="1609344"/>
+            <a:ext cx="2286000" cy="274320"/>
           </a:xfrm>
           <a:prstGeom prst="rect">
             <a:avLst/>
@@ -5933,7 +6173,7 @@
           <a:lstStyle/>
           <a:p>
             <a:pPr algn="l">
-              <a:defRPr sz="1300" b="1">
+              <a:defRPr sz="1200" b="1">
                 <a:solidFill>
                   <a:srgbClr val="2F5BA8"/>
                 </a:solidFill>
@@ -5941,7 +6181,7 @@
               </a:defRPr>
             </a:pPr>
             <a:r>
-              <a:t>DEMOSTRACIÓN</a:t>
+              <a:t>CONSOLA</a:t>
             </a:r>
           </a:p>
         </p:txBody>
@@ -5954,8 +6194,140 @@
         </p:nvSpPr>
         <p:spPr>
           <a:xfrm>
-            <a:off x="932688" y="2212848"/>
-            <a:ext cx="9966960" cy="3246120"/>
+            <a:off x="914400" y="2057400"/>
+            <a:ext cx="6355080" cy="3383280"/>
+          </a:xfrm>
+          <a:prstGeom prst="rect">
+            <a:avLst/>
+          </a:prstGeom>
+          <a:noFill/>
+        </p:spPr>
+        <p:txBody>
+          <a:bodyPr wrap="none" lIns="164592" rIns="164592" tIns="109728" bIns="109728">
+            <a:spAutoFit/>
+          </a:bodyPr>
+          <a:lstStyle/>
+          <a:p>
+            <a:pPr>
+              <a:spcAft>
+                <a:spcPts val="0"/>
+              </a:spcAft>
+              <a:defRPr sz="2000">
+                <a:solidFill>
+                  <a:srgbClr val="FFFFFF"/>
+                </a:solidFill>
+                <a:latin typeface="Liberation Mono"/>
+              </a:defRPr>
+            </a:pPr>
+            <a:r>
+              <a:t>Hola, soy MiniJarvis.</a:t>
+            </a:r>
+            <a:br/>
+            <a:r>
+              <a:t>¿Cómo te llamas? Laura</a:t>
+            </a:r>
+            <a:br/>
+            <a:r>
+              <a:t>Encantado, Laura.</a:t>
+            </a:r>
+            <a:br/>
+            <a:r>
+              <a:t>Estoy aprendiendo la base de Java.</a:t>
+            </a:r>
+          </a:p>
+        </p:txBody>
+      </p:sp>
+      <p:sp>
+        <p:nvSpPr>
+          <p:cNvPr id="11" name="Rounded Rectangle 10"/>
+          <p:cNvSpPr/>
+          <p:nvPr/>
+        </p:nvSpPr>
+        <p:spPr>
+          <a:xfrm>
+            <a:off x="7936992" y="1371600"/>
+            <a:ext cx="3584448" cy="4526280"/>
+          </a:xfrm>
+          <a:prstGeom prst="roundRect">
+            <a:avLst/>
+          </a:prstGeom>
+          <a:solidFill>
+            <a:srgbClr val="FFFFFF"/>
+          </a:solidFill>
+          <a:ln>
+            <a:solidFill>
+              <a:srgbClr val="E5E9EF"/>
+            </a:solidFill>
+          </a:ln>
+        </p:spPr>
+        <p:style>
+          <a:lnRef idx="1">
+            <a:schemeClr val="accent1"/>
+          </a:lnRef>
+          <a:fillRef idx="3">
+            <a:schemeClr val="accent1"/>
+          </a:fillRef>
+          <a:effectRef idx="2">
+            <a:schemeClr val="accent1"/>
+          </a:effectRef>
+          <a:fontRef idx="minor">
+            <a:schemeClr val="lt1"/>
+          </a:fontRef>
+        </p:style>
+        <p:txBody>
+          <a:bodyPr rtlCol="0" anchor="ctr"/>
+          <a:lstStyle/>
+          <a:p>
+            <a:pPr algn="ctr"/>
+          </a:p>
+        </p:txBody>
+      </p:sp>
+      <p:sp>
+        <p:nvSpPr>
+          <p:cNvPr id="12" name="TextBox 11"/>
+          <p:cNvSpPr txBox="1"/>
+          <p:nvPr/>
+        </p:nvSpPr>
+        <p:spPr>
+          <a:xfrm>
+            <a:off x="8211312" y="1627632"/>
+            <a:ext cx="3017520" cy="320040"/>
+          </a:xfrm>
+          <a:prstGeom prst="rect">
+            <a:avLst/>
+          </a:prstGeom>
+          <a:noFill/>
+        </p:spPr>
+        <p:txBody>
+          <a:bodyPr wrap="square" lIns="45720" rIns="45720" tIns="36576" bIns="36576" anchor="t">
+            <a:spAutoFit/>
+          </a:bodyPr>
+          <a:lstStyle/>
+          <a:p>
+            <a:pPr algn="l">
+              <a:defRPr sz="1200" b="1">
+                <a:solidFill>
+                  <a:srgbClr val="2F5BA8"/>
+                </a:solidFill>
+                <a:latin typeface="Aptos"/>
+              </a:defRPr>
+            </a:pPr>
+            <a:r>
+              <a:t>QUÉ DEMUESTRA</a:t>
+            </a:r>
+          </a:p>
+        </p:txBody>
+      </p:sp>
+      <p:sp>
+        <p:nvSpPr>
+          <p:cNvPr id="13" name="TextBox 12"/>
+          <p:cNvSpPr txBox="1"/>
+          <p:nvPr/>
+        </p:nvSpPr>
+        <p:spPr>
+          <a:xfrm>
+            <a:off x="8211312" y="2148840"/>
+            <a:ext cx="2889504" cy="3246120"/>
           </a:xfrm>
           <a:prstGeom prst="rect">
             <a:avLst/>
@@ -5972,63 +6344,15 @@
               <a:spcAft>
                 <a:spcPts val="900"/>
               </a:spcAft>
-              <a:defRPr sz="2200">
+              <a:defRPr sz="1800">
                 <a:solidFill>
-                  <a:srgbClr val="FFFFFF"/>
+                  <a:srgbClr val="1C2330"/>
                 </a:solidFill>
                 <a:latin typeface="Aptos"/>
               </a:defRPr>
             </a:pPr>
             <a:r>
-              <a:t>•  Encantado, Laura.</a:t>
-            </a:r>
-          </a:p>
-          <a:p>
-            <a:pPr>
-              <a:spcAft>
-                <a:spcPts val="900"/>
-              </a:spcAft>
-              <a:defRPr sz="2200">
-                <a:solidFill>
-                  <a:srgbClr val="FFFFFF"/>
-                </a:solidFill>
-                <a:latin typeface="Aptos"/>
-              </a:defRPr>
-            </a:pPr>
-            <a:r>
-              <a:t>•  Estoy aprendiendo la base de Java.</a:t>
-            </a:r>
-          </a:p>
-          <a:p>
-            <a:pPr>
-              <a:spcAft>
-                <a:spcPts val="900"/>
-              </a:spcAft>
-              <a:defRPr sz="2200">
-                <a:solidFill>
-                  <a:srgbClr val="FFFFFF"/>
-                </a:solidFill>
-                <a:latin typeface="Aptos"/>
-              </a:defRPr>
-            </a:pPr>
-            <a:r>
-              <a:t>•  D3 · ¿Qué hace bueno a un primer programa? CORRECTO: Hace la tarea pedida y podemos comprobarlo. \| EFICIENTE: No añade trabajo o complejidad que no necesita.</a:t>
-            </a:r>
-          </a:p>
-          <a:p>
-            <a:pPr>
-              <a:spcAft>
-                <a:spcPts val="900"/>
-              </a:spcAft>
-              <a:defRPr sz="2200">
-                <a:solidFill>
-                  <a:srgbClr val="FFFFFF"/>
-                </a:solidFill>
-                <a:latin typeface="Aptos"/>
-              </a:defRPr>
-            </a:pPr>
-            <a:r>
-              <a:t>•  \| MANTENIBLE: Se entiende y puede modificarse sin romperlo.</a:t>
+              <a:t>•  Describe exactamente lo que existe: no promete memoria ni inteligencia que todavía no tiene.</a:t>
             </a:r>
           </a:p>
         </p:txBody>
@@ -6168,7 +6492,7 @@
               </a:defRPr>
             </a:pPr>
             <a:r>
-              <a:t>APLICAR Y DECIDIR</a:t>
+              <a:t>COMPRENDER</a:t>
             </a:r>
           </a:p>
         </p:txBody>
@@ -6204,7 +6528,7 @@
               </a:defRPr>
             </a:pPr>
             <a:r>
-              <a:t>Actividad central · 1</a:t>
+              <a:t>De una idea a requisitos comprobables</a:t>
             </a:r>
           </a:p>
         </p:txBody>
@@ -6296,8 +6620,8 @@
         </p:nvSpPr>
         <p:spPr>
           <a:xfrm>
-            <a:off x="658368" y="1307592"/>
-            <a:ext cx="10835640" cy="1049274"/>
+            <a:off x="566928" y="1261872"/>
+            <a:ext cx="5212080" cy="2199132"/>
           </a:xfrm>
           <a:prstGeom prst="roundRect">
             <a:avLst/>
@@ -6341,8 +6665,8 @@
         </p:nvSpPr>
         <p:spPr>
           <a:xfrm>
-            <a:off x="850392" y="1453895"/>
-            <a:ext cx="685800" cy="384048"/>
+            <a:off x="768096" y="1426463"/>
+            <a:ext cx="384048" cy="347472"/>
           </a:xfrm>
           <a:prstGeom prst="rect">
             <a:avLst/>
@@ -6356,7 +6680,7 @@
           <a:lstStyle/>
           <a:p>
             <a:pPr algn="l">
-              <a:defRPr sz="1200" b="1">
+              <a:defRPr sz="1500" b="1">
                 <a:solidFill>
                   <a:srgbClr val="2F5BA8"/>
                 </a:solidFill>
@@ -6364,7 +6688,7 @@
               </a:defRPr>
             </a:pPr>
             <a:r>
-              <a:t>PASO 1</a:t>
+              <a:t>01</a:t>
             </a:r>
           </a:p>
         </p:txBody>
@@ -6377,8 +6701,8 @@
         </p:nvSpPr>
         <p:spPr>
           <a:xfrm>
-            <a:off x="1664208" y="1417319"/>
-            <a:ext cx="9464040" cy="829818"/>
+            <a:off x="1225295" y="1426463"/>
+            <a:ext cx="4434840" cy="1961388"/>
           </a:xfrm>
           <a:prstGeom prst="rect">
             <a:avLst/>
@@ -6392,7 +6716,7 @@
           <a:lstStyle/>
           <a:p>
             <a:pPr algn="l">
-              <a:defRPr sz="2000" b="0">
+              <a:defRPr sz="1800" b="0">
                 <a:solidFill>
                   <a:srgbClr val="1C2330"/>
                 </a:solidFill>
@@ -6400,7 +6724,7 @@
               </a:defRPr>
             </a:pPr>
             <a:r>
-              <a:t>Predice antes de ejecutar cuando haya código.</a:t>
+              <a:t>Muestra · pide · guarda · calcula · ejecuta · explica: verbos que producen resultados observables.</a:t>
             </a:r>
           </a:p>
         </p:txBody>
@@ -6413,8 +6737,8 @@
         </p:nvSpPr>
         <p:spPr>
           <a:xfrm>
-            <a:off x="658368" y="2542032"/>
-            <a:ext cx="10835640" cy="1049274"/>
+            <a:off x="6007608" y="1261872"/>
+            <a:ext cx="5212080" cy="2199132"/>
           </a:xfrm>
           <a:prstGeom prst="roundRect">
             <a:avLst/>
@@ -6458,8 +6782,8 @@
         </p:nvSpPr>
         <p:spPr>
           <a:xfrm>
-            <a:off x="850392" y="2688336"/>
-            <a:ext cx="685800" cy="384048"/>
+            <a:off x="6208776" y="1426463"/>
+            <a:ext cx="384048" cy="347472"/>
           </a:xfrm>
           <a:prstGeom prst="rect">
             <a:avLst/>
@@ -6473,7 +6797,7 @@
           <a:lstStyle/>
           <a:p>
             <a:pPr algn="l">
-              <a:defRPr sz="1200" b="1">
+              <a:defRPr sz="1500" b="1">
                 <a:solidFill>
                   <a:srgbClr val="2F5BA8"/>
                 </a:solidFill>
@@ -6481,7 +6805,7 @@
               </a:defRPr>
             </a:pPr>
             <a:r>
-              <a:t>PASO 2</a:t>
+              <a:t>02</a:t>
             </a:r>
           </a:p>
         </p:txBody>
@@ -6494,8 +6818,8 @@
         </p:nvSpPr>
         <p:spPr>
           <a:xfrm>
-            <a:off x="1664208" y="2651760"/>
-            <a:ext cx="9464040" cy="829818"/>
+            <a:off x="6665976" y="1426463"/>
+            <a:ext cx="4434840" cy="1961388"/>
           </a:xfrm>
           <a:prstGeom prst="rect">
             <a:avLst/>
@@ -6509,7 +6833,7 @@
           <a:lstStyle/>
           <a:p>
             <a:pPr algn="l">
-              <a:defRPr sz="2000" b="0">
+              <a:defRPr sz="1800" b="0">
                 <a:solidFill>
                   <a:srgbClr val="1C2330"/>
                 </a:solidFill>
@@ -6517,7 +6841,7 @@
               </a:defRPr>
             </a:pPr>
             <a:r>
-              <a:t>Realiza la micropráctica o modificación prevista.</a:t>
+              <a:t>Correcto: cumple la tarea y supera los casos previstos.</a:t>
             </a:r>
           </a:p>
         </p:txBody>
@@ -6530,8 +6854,8 @@
         </p:nvSpPr>
         <p:spPr>
           <a:xfrm>
-            <a:off x="658368" y="3776472"/>
-            <a:ext cx="10835640" cy="1049274"/>
+            <a:off x="566928" y="3662172"/>
+            <a:ext cx="5212080" cy="2199132"/>
           </a:xfrm>
           <a:prstGeom prst="roundRect">
             <a:avLst/>
@@ -6575,8 +6899,8 @@
         </p:nvSpPr>
         <p:spPr>
           <a:xfrm>
-            <a:off x="850392" y="3922776"/>
-            <a:ext cx="685800" cy="384048"/>
+            <a:off x="768096" y="3826763"/>
+            <a:ext cx="384048" cy="347472"/>
           </a:xfrm>
           <a:prstGeom prst="rect">
             <a:avLst/>
@@ -6590,7 +6914,7 @@
           <a:lstStyle/>
           <a:p>
             <a:pPr algn="l">
-              <a:defRPr sz="1200" b="1">
+              <a:defRPr sz="1500" b="1">
                 <a:solidFill>
                   <a:srgbClr val="2F5BA8"/>
                 </a:solidFill>
@@ -6598,7 +6922,7 @@
               </a:defRPr>
             </a:pPr>
             <a:r>
-              <a:t>PASO 3</a:t>
+              <a:t>03</a:t>
             </a:r>
           </a:p>
         </p:txBody>
@@ -6611,8 +6935,8 @@
         </p:nvSpPr>
         <p:spPr>
           <a:xfrm>
-            <a:off x="1664208" y="3886200"/>
-            <a:ext cx="9464040" cy="829818"/>
+            <a:off x="1225295" y="3826763"/>
+            <a:ext cx="4434840" cy="1961388"/>
           </a:xfrm>
           <a:prstGeom prst="rect">
             <a:avLst/>
@@ -6626,7 +6950,7 @@
           <a:lstStyle/>
           <a:p>
             <a:pPr algn="l">
-              <a:defRPr sz="2000" b="0">
+              <a:defRPr sz="1800" b="0">
                 <a:solidFill>
                   <a:srgbClr val="1C2330"/>
                 </a:solidFill>
@@ -6634,7 +6958,7 @@
               </a:defRPr>
             </a:pPr>
             <a:r>
-              <a:t>Prueba el caso normal y, cuando exista una decisión o conversión, también el caso alternativo o erróneo.</a:t>
+              <a:t>Sencillo: no añade trabajo o complejidad innecesaria.</a:t>
             </a:r>
           </a:p>
         </p:txBody>
@@ -6647,8 +6971,8 @@
         </p:nvSpPr>
         <p:spPr>
           <a:xfrm>
-            <a:off x="658368" y="5010912"/>
-            <a:ext cx="10835640" cy="1049274"/>
+            <a:off x="6007608" y="3662172"/>
+            <a:ext cx="5212080" cy="2199132"/>
           </a:xfrm>
           <a:prstGeom prst="roundRect">
             <a:avLst/>
@@ -6692,8 +7016,8 @@
         </p:nvSpPr>
         <p:spPr>
           <a:xfrm>
-            <a:off x="850392" y="5157216"/>
-            <a:ext cx="685800" cy="384048"/>
+            <a:off x="6208776" y="3826763"/>
+            <a:ext cx="384048" cy="347472"/>
           </a:xfrm>
           <a:prstGeom prst="rect">
             <a:avLst/>
@@ -6707,7 +7031,7 @@
           <a:lstStyle/>
           <a:p>
             <a:pPr algn="l">
-              <a:defRPr sz="1200" b="1">
+              <a:defRPr sz="1500" b="1">
                 <a:solidFill>
                   <a:srgbClr val="2F5BA8"/>
                 </a:solidFill>
@@ -6715,7 +7039,7 @@
               </a:defRPr>
             </a:pPr>
             <a:r>
-              <a:t>PASO 4</a:t>
+              <a:t>04</a:t>
             </a:r>
           </a:p>
         </p:txBody>
@@ -6728,8 +7052,8 @@
         </p:nvSpPr>
         <p:spPr>
           <a:xfrm>
-            <a:off x="1664208" y="5120640"/>
-            <a:ext cx="9464040" cy="829818"/>
+            <a:off x="6665976" y="3826763"/>
+            <a:ext cx="4434840" cy="1961388"/>
           </a:xfrm>
           <a:prstGeom prst="rect">
             <a:avLst/>
@@ -6743,7 +7067,7 @@
           <a:lstStyle/>
           <a:p>
             <a:pPr algn="l">
-              <a:defRPr sz="2000" b="0">
+              <a:defRPr sz="1800" b="0">
                 <a:solidFill>
                   <a:srgbClr val="1C2330"/>
                 </a:solidFill>
@@ -6751,7 +7075,7 @@
               </a:defRPr>
             </a:pPr>
             <a:r>
-              <a:t>Conserva el código o resultado en el repositorio o espacio indicado.</a:t>
+              <a:t>Mantenible: se entiende y puede modificarse sin romperse.</a:t>
             </a:r>
           </a:p>
         </p:txBody>
@@ -6927,7 +7251,7 @@
               </a:defRPr>
             </a:pPr>
             <a:r>
-              <a:t>Actividad central · 2</a:t>
+              <a:t>Delimita el incremento H1</a:t>
             </a:r>
           </a:p>
         </p:txBody>
@@ -7020,7 +7344,7 @@
         <p:spPr>
           <a:xfrm>
             <a:off x="658368" y="1307592"/>
-            <a:ext cx="10835640" cy="2226564"/>
+            <a:ext cx="10835640" cy="1049274"/>
           </a:xfrm>
           <a:prstGeom prst="roundRect">
             <a:avLst/>
@@ -7087,7 +7411,7 @@
               </a:defRPr>
             </a:pPr>
             <a:r>
-              <a:t>PASO 6</a:t>
+              <a:t>PASO 1</a:t>
             </a:r>
           </a:p>
         </p:txBody>
@@ -7101,7 +7425,7 @@
         <p:spPr>
           <a:xfrm>
             <a:off x="1664208" y="1417319"/>
-            <a:ext cx="9464040" cy="2007108"/>
+            <a:ext cx="9464040" cy="829818"/>
           </a:xfrm>
           <a:prstGeom prst="rect">
             <a:avLst/>
@@ -7123,7 +7447,7 @@
               </a:defRPr>
             </a:pPr>
             <a:r>
-              <a:t>Registra una sola entrada en el diario individual; no crees un informe paralelo.</a:t>
+              <a:t>Clasifica cada propuesta en H1 ahora, hito posterior o fuera del reto.</a:t>
             </a:r>
           </a:p>
         </p:txBody>
@@ -7136,8 +7460,8 @@
         </p:nvSpPr>
         <p:spPr>
           <a:xfrm>
-            <a:off x="658368" y="3776472"/>
-            <a:ext cx="10835640" cy="2226564"/>
+            <a:off x="658368" y="2542032"/>
+            <a:ext cx="10835640" cy="1049274"/>
           </a:xfrm>
           <a:prstGeom prst="roundRect">
             <a:avLst/>
@@ -7181,7 +7505,7 @@
         </p:nvSpPr>
         <p:spPr>
           <a:xfrm>
-            <a:off x="850392" y="3922776"/>
+            <a:off x="850392" y="2688336"/>
             <a:ext cx="685800" cy="384048"/>
           </a:xfrm>
           <a:prstGeom prst="rect">
@@ -7204,7 +7528,7 @@
               </a:defRPr>
             </a:pPr>
             <a:r>
-              <a:t>PASO 7</a:t>
+              <a:t>PASO 2</a:t>
             </a:r>
           </a:p>
         </p:txBody>
@@ -7217,8 +7541,8 @@
         </p:nvSpPr>
         <p:spPr>
           <a:xfrm>
-            <a:off x="1664208" y="3886200"/>
-            <a:ext cx="9464040" cy="2007108"/>
+            <a:off x="1664208" y="2651760"/>
+            <a:ext cx="9464040" cy="829818"/>
           </a:xfrm>
           <a:prstGeom prst="rect">
             <a:avLst/>
@@ -7240,7 +7564,241 @@
               </a:defRPr>
             </a:pPr>
             <a:r>
-              <a:t>¿Qué puedes señalar, explicar y probar al terminar este checkpoint?</a:t>
+              <a:t>Escribe entre 4 y 6 requisitos observables.</a:t>
+            </a:r>
+          </a:p>
+        </p:txBody>
+      </p:sp>
+      <p:sp>
+        <p:nvSpPr>
+          <p:cNvPr id="14" name="Rounded Rectangle 13"/>
+          <p:cNvSpPr/>
+          <p:nvPr/>
+        </p:nvSpPr>
+        <p:spPr>
+          <a:xfrm>
+            <a:off x="658368" y="3776472"/>
+            <a:ext cx="10835640" cy="1049274"/>
+          </a:xfrm>
+          <a:prstGeom prst="roundRect">
+            <a:avLst/>
+          </a:prstGeom>
+          <a:solidFill>
+            <a:srgbClr val="FFFFFF"/>
+          </a:solidFill>
+          <a:ln>
+            <a:solidFill>
+              <a:srgbClr val="E5E9EF"/>
+            </a:solidFill>
+          </a:ln>
+        </p:spPr>
+        <p:style>
+          <a:lnRef idx="1">
+            <a:schemeClr val="accent1"/>
+          </a:lnRef>
+          <a:fillRef idx="3">
+            <a:schemeClr val="accent1"/>
+          </a:fillRef>
+          <a:effectRef idx="2">
+            <a:schemeClr val="accent1"/>
+          </a:effectRef>
+          <a:fontRef idx="minor">
+            <a:schemeClr val="lt1"/>
+          </a:fontRef>
+        </p:style>
+        <p:txBody>
+          <a:bodyPr rtlCol="0" anchor="ctr"/>
+          <a:lstStyle/>
+          <a:p>
+            <a:pPr algn="ctr"/>
+          </a:p>
+        </p:txBody>
+      </p:sp>
+      <p:sp>
+        <p:nvSpPr>
+          <p:cNvPr id="15" name="TextBox 14"/>
+          <p:cNvSpPr txBox="1"/>
+          <p:nvPr/>
+        </p:nvSpPr>
+        <p:spPr>
+          <a:xfrm>
+            <a:off x="850392" y="3922776"/>
+            <a:ext cx="685800" cy="384048"/>
+          </a:xfrm>
+          <a:prstGeom prst="rect">
+            <a:avLst/>
+          </a:prstGeom>
+          <a:noFill/>
+        </p:spPr>
+        <p:txBody>
+          <a:bodyPr wrap="square" lIns="45720" rIns="45720" tIns="36576" bIns="36576" anchor="t">
+            <a:spAutoFit/>
+          </a:bodyPr>
+          <a:lstStyle/>
+          <a:p>
+            <a:pPr algn="l">
+              <a:defRPr sz="1200" b="1">
+                <a:solidFill>
+                  <a:srgbClr val="2F5BA8"/>
+                </a:solidFill>
+                <a:latin typeface="Aptos"/>
+              </a:defRPr>
+            </a:pPr>
+            <a:r>
+              <a:t>PASO 3</a:t>
+            </a:r>
+          </a:p>
+        </p:txBody>
+      </p:sp>
+      <p:sp>
+        <p:nvSpPr>
+          <p:cNvPr id="16" name="TextBox 15"/>
+          <p:cNvSpPr txBox="1"/>
+          <p:nvPr/>
+        </p:nvSpPr>
+        <p:spPr>
+          <a:xfrm>
+            <a:off x="1664208" y="3886200"/>
+            <a:ext cx="9464040" cy="829818"/>
+          </a:xfrm>
+          <a:prstGeom prst="rect">
+            <a:avLst/>
+          </a:prstGeom>
+          <a:noFill/>
+        </p:spPr>
+        <p:txBody>
+          <a:bodyPr wrap="square" lIns="45720" rIns="45720" tIns="36576" bIns="36576" anchor="t">
+            <a:spAutoFit/>
+          </a:bodyPr>
+          <a:lstStyle/>
+          <a:p>
+            <a:pPr algn="l">
+              <a:defRPr sz="2000" b="0">
+                <a:solidFill>
+                  <a:srgbClr val="1C2330"/>
+                </a:solidFill>
+                <a:latin typeface="Aptos"/>
+              </a:defRPr>
+            </a:pPr>
+            <a:r>
+              <a:t>Añade 2 o 3 límites explícitos.</a:t>
+            </a:r>
+          </a:p>
+        </p:txBody>
+      </p:sp>
+      <p:sp>
+        <p:nvSpPr>
+          <p:cNvPr id="17" name="Rounded Rectangle 16"/>
+          <p:cNvSpPr/>
+          <p:nvPr/>
+        </p:nvSpPr>
+        <p:spPr>
+          <a:xfrm>
+            <a:off x="658368" y="5010912"/>
+            <a:ext cx="10835640" cy="1049274"/>
+          </a:xfrm>
+          <a:prstGeom prst="roundRect">
+            <a:avLst/>
+          </a:prstGeom>
+          <a:solidFill>
+            <a:srgbClr val="FFFFFF"/>
+          </a:solidFill>
+          <a:ln>
+            <a:solidFill>
+              <a:srgbClr val="E5E9EF"/>
+            </a:solidFill>
+          </a:ln>
+        </p:spPr>
+        <p:style>
+          <a:lnRef idx="1">
+            <a:schemeClr val="accent1"/>
+          </a:lnRef>
+          <a:fillRef idx="3">
+            <a:schemeClr val="accent1"/>
+          </a:fillRef>
+          <a:effectRef idx="2">
+            <a:schemeClr val="accent1"/>
+          </a:effectRef>
+          <a:fontRef idx="minor">
+            <a:schemeClr val="lt1"/>
+          </a:fontRef>
+        </p:style>
+        <p:txBody>
+          <a:bodyPr rtlCol="0" anchor="ctr"/>
+          <a:lstStyle/>
+          <a:p>
+            <a:pPr algn="ctr"/>
+          </a:p>
+        </p:txBody>
+      </p:sp>
+      <p:sp>
+        <p:nvSpPr>
+          <p:cNvPr id="18" name="TextBox 17"/>
+          <p:cNvSpPr txBox="1"/>
+          <p:nvPr/>
+        </p:nvSpPr>
+        <p:spPr>
+          <a:xfrm>
+            <a:off x="850392" y="5157216"/>
+            <a:ext cx="685800" cy="384048"/>
+          </a:xfrm>
+          <a:prstGeom prst="rect">
+            <a:avLst/>
+          </a:prstGeom>
+          <a:noFill/>
+        </p:spPr>
+        <p:txBody>
+          <a:bodyPr wrap="square" lIns="45720" rIns="45720" tIns="36576" bIns="36576" anchor="t">
+            <a:spAutoFit/>
+          </a:bodyPr>
+          <a:lstStyle/>
+          <a:p>
+            <a:pPr algn="l">
+              <a:defRPr sz="1200" b="1">
+                <a:solidFill>
+                  <a:srgbClr val="2F5BA8"/>
+                </a:solidFill>
+                <a:latin typeface="Aptos"/>
+              </a:defRPr>
+            </a:pPr>
+            <a:r>
+              <a:t>PASO 4</a:t>
+            </a:r>
+          </a:p>
+        </p:txBody>
+      </p:sp>
+      <p:sp>
+        <p:nvSpPr>
+          <p:cNvPr id="19" name="TextBox 18"/>
+          <p:cNvSpPr txBox="1"/>
+          <p:nvPr/>
+        </p:nvSpPr>
+        <p:spPr>
+          <a:xfrm>
+            <a:off x="1664208" y="5120640"/>
+            <a:ext cx="9464040" cy="829818"/>
+          </a:xfrm>
+          <a:prstGeom prst="rect">
+            <a:avLst/>
+          </a:prstGeom>
+          <a:noFill/>
+        </p:spPr>
+        <p:txBody>
+          <a:bodyPr wrap="square" lIns="45720" rIns="45720" tIns="36576" bIns="36576" anchor="t">
+            <a:spAutoFit/>
+          </a:bodyPr>
+          <a:lstStyle/>
+          <a:p>
+            <a:pPr algn="l">
+              <a:defRPr sz="2000" b="0">
+                <a:solidFill>
+                  <a:srgbClr val="1C2330"/>
+                </a:solidFill>
+                <a:latin typeface="Aptos"/>
+              </a:defRPr>
+            </a:pPr>
+            <a:r>
+              <a:t>Para cada requisito indica cómo lo comprobarás.</a:t>
             </a:r>
           </a:p>
         </p:txBody>
@@ -7416,7 +7974,7 @@
               </a:defRPr>
             </a:pPr>
             <a:r>
-              <a:t>Evidencia y comprobación</a:t>
+              <a:t>Puerta de avance</a:t>
             </a:r>
           </a:p>
         </p:txBody>
@@ -7554,7 +8112,7 @@
         <p:spPr>
           <a:xfrm>
             <a:off x="1389888" y="1280160"/>
-            <a:ext cx="9829800" cy="1624584"/>
+            <a:ext cx="9829800" cy="1209294"/>
           </a:xfrm>
           <a:prstGeom prst="rect">
             <a:avLst/>
@@ -7576,7 +8134,7 @@
               </a:defRPr>
             </a:pPr>
             <a:r>
-              <a:t>conserva el código o la prueba en el lugar indicado por la sesión;</a:t>
+              <a:t>Puedo describir H1 en una frase.</a:t>
             </a:r>
           </a:p>
         </p:txBody>
@@ -7589,7 +8147,7 @@
         </p:nvSpPr>
         <p:spPr>
           <a:xfrm>
-            <a:off x="713232" y="2959607"/>
+            <a:off x="713232" y="2544318"/>
             <a:ext cx="420624" cy="420624"/>
           </a:xfrm>
           <a:prstGeom prst="roundRect">
@@ -7634,8 +8192,8 @@
         </p:nvSpPr>
         <p:spPr>
           <a:xfrm>
-            <a:off x="1389888" y="2941319"/>
-            <a:ext cx="9829800" cy="1624584"/>
+            <a:off x="1389888" y="2526029"/>
+            <a:ext cx="9829800" cy="1209294"/>
           </a:xfrm>
           <a:prstGeom prst="rect">
             <a:avLst/>
@@ -7657,7 +8215,7 @@
               </a:defRPr>
             </a:pPr>
             <a:r>
-              <a:t>añade una sola entrada al diario individual con prueba, bloqueo y siguiente paso;</a:t>
+              <a:t>Cada requisito tiene una prueba observable.</a:t>
             </a:r>
           </a:p>
         </p:txBody>
@@ -7670,7 +8228,7 @@
         </p:nvSpPr>
         <p:spPr>
           <a:xfrm>
-            <a:off x="713232" y="4620767"/>
+            <a:off x="713232" y="3790187"/>
             <a:ext cx="420624" cy="420624"/>
           </a:xfrm>
           <a:prstGeom prst="roundRect">
@@ -7715,8 +8273,8 @@
         </p:nvSpPr>
         <p:spPr>
           <a:xfrm>
-            <a:off x="1389888" y="4602480"/>
-            <a:ext cx="9829800" cy="1624584"/>
+            <a:off x="1389888" y="3771900"/>
+            <a:ext cx="9829800" cy="1209294"/>
           </a:xfrm>
           <a:prstGeom prst="rect">
             <a:avLst/>
@@ -7738,7 +8296,88 @@
               </a:defRPr>
             </a:pPr>
             <a:r>
-              <a:t>no copies la misma reflexión en otro documento; el Site personal seleccionará evidencias al cerrar H1.</a:t>
+              <a:t>Puedo justificar por qué una función queda fuera.</a:t>
+            </a:r>
+          </a:p>
+        </p:txBody>
+      </p:sp>
+      <p:sp>
+        <p:nvSpPr>
+          <p:cNvPr id="14" name="Rounded Rectangle 13"/>
+          <p:cNvSpPr/>
+          <p:nvPr/>
+        </p:nvSpPr>
+        <p:spPr>
+          <a:xfrm>
+            <a:off x="713232" y="5036057"/>
+            <a:ext cx="420624" cy="420624"/>
+          </a:xfrm>
+          <a:prstGeom prst="roundRect">
+            <a:avLst/>
+          </a:prstGeom>
+          <a:solidFill>
+            <a:srgbClr val="FFFFFF"/>
+          </a:solidFill>
+          <a:ln>
+            <a:solidFill>
+              <a:srgbClr val="2F5BA8"/>
+            </a:solidFill>
+          </a:ln>
+        </p:spPr>
+        <p:style>
+          <a:lnRef idx="1">
+            <a:schemeClr val="accent1"/>
+          </a:lnRef>
+          <a:fillRef idx="3">
+            <a:schemeClr val="accent1"/>
+          </a:fillRef>
+          <a:effectRef idx="2">
+            <a:schemeClr val="accent1"/>
+          </a:effectRef>
+          <a:fontRef idx="minor">
+            <a:schemeClr val="lt1"/>
+          </a:fontRef>
+        </p:style>
+        <p:txBody>
+          <a:bodyPr rtlCol="0" anchor="ctr"/>
+          <a:lstStyle/>
+          <a:p>
+            <a:pPr algn="ctr"/>
+          </a:p>
+        </p:txBody>
+      </p:sp>
+      <p:sp>
+        <p:nvSpPr>
+          <p:cNvPr id="15" name="TextBox 14"/>
+          <p:cNvSpPr txBox="1"/>
+          <p:nvPr/>
+        </p:nvSpPr>
+        <p:spPr>
+          <a:xfrm>
+            <a:off x="1389888" y="5017770"/>
+            <a:ext cx="9829800" cy="1209294"/>
+          </a:xfrm>
+          <a:prstGeom prst="rect">
+            <a:avLst/>
+          </a:prstGeom>
+          <a:noFill/>
+        </p:spPr>
+        <p:txBody>
+          <a:bodyPr wrap="square" lIns="45720" rIns="45720" tIns="36576" bIns="36576" anchor="t">
+            <a:spAutoFit/>
+          </a:bodyPr>
+          <a:lstStyle/>
+          <a:p>
+            <a:pPr algn="l">
+              <a:defRPr sz="1900" b="0">
+                <a:solidFill>
+                  <a:srgbClr val="1C2330"/>
+                </a:solidFill>
+                <a:latin typeface="Aptos"/>
+              </a:defRPr>
+            </a:pPr>
+            <a:r>
+              <a:t>He definido una evidencia concreta y el siguiente paso.</a:t>
             </a:r>
           </a:p>
         </p:txBody>
@@ -7878,7 +8517,7 @@
               </a:defRPr>
             </a:pPr>
             <a:r>
-              <a:t>LÍMITES QUE PROTEGEN EL APRENDIZAJE</a:t>
+              <a:t>EXPLICAR Y DEFENDER</a:t>
             </a:r>
           </a:p>
         </p:txBody>
@@ -7914,7 +8553,7 @@
               </a:defRPr>
             </a:pPr>
             <a:r>
-              <a:t>Seguridad y uso responsable</a:t>
+              <a:t>Defiende el alcance</a:t>
             </a:r>
           </a:p>
         </p:txBody>
@@ -8007,17 +8646,17 @@
         <p:spPr>
           <a:xfrm>
             <a:off x="621792" y="1298448"/>
-            <a:ext cx="5230368" cy="4553712"/>
+            <a:ext cx="10927080" cy="1828800"/>
           </a:xfrm>
           <a:prstGeom prst="roundRect">
             <a:avLst/>
           </a:prstGeom>
           <a:solidFill>
-            <a:srgbClr val="FFFFFF"/>
+            <a:srgbClr val="2F5BA8"/>
           </a:solidFill>
           <a:ln>
             <a:solidFill>
-              <a:srgbClr val="E5E9EF"/>
+              <a:srgbClr val="2F5BA8"/>
             </a:solidFill>
           </a:ln>
         </p:spPr>
@@ -8045,57 +8684,14 @@
       </p:sp>
       <p:sp>
         <p:nvSpPr>
-          <p:cNvPr id="9" name="Rounded Rectangle 8"/>
-          <p:cNvSpPr/>
-          <p:nvPr/>
-        </p:nvSpPr>
-        <p:spPr>
-          <a:xfrm>
-            <a:off x="841248" y="1527048"/>
-            <a:ext cx="237744" cy="4096512"/>
-          </a:xfrm>
-          <a:prstGeom prst="roundRect">
-            <a:avLst/>
-          </a:prstGeom>
-          <a:solidFill>
-            <a:srgbClr val="247E5C"/>
-          </a:solidFill>
-          <a:ln>
-            <a:noFill/>
-          </a:ln>
-        </p:spPr>
-        <p:style>
-          <a:lnRef idx="1">
-            <a:schemeClr val="accent1"/>
-          </a:lnRef>
-          <a:fillRef idx="3">
-            <a:schemeClr val="accent1"/>
-          </a:fillRef>
-          <a:effectRef idx="2">
-            <a:schemeClr val="accent1"/>
-          </a:effectRef>
-          <a:fontRef idx="minor">
-            <a:schemeClr val="lt1"/>
-          </a:fontRef>
-        </p:style>
-        <p:txBody>
-          <a:bodyPr rtlCol="0" anchor="ctr"/>
-          <a:lstStyle/>
-          <a:p>
-            <a:pPr algn="ctr"/>
-          </a:p>
-        </p:txBody>
-      </p:sp>
-      <p:sp>
-        <p:nvSpPr>
-          <p:cNvPr id="10" name="TextBox 9"/>
+          <p:cNvPr id="9" name="TextBox 8"/>
           <p:cNvSpPr txBox="1"/>
           <p:nvPr/>
         </p:nvSpPr>
         <p:spPr>
           <a:xfrm>
-            <a:off x="1280160" y="1527048"/>
-            <a:ext cx="4224528" cy="4160520"/>
+            <a:off x="932688" y="1591056"/>
+            <a:ext cx="10241280" cy="256032"/>
           </a:xfrm>
           <a:prstGeom prst="rect">
             <a:avLst/>
@@ -8109,117 +8705,29 @@
           <a:lstStyle/>
           <a:p>
             <a:pPr algn="l">
-              <a:defRPr sz="1900" b="0">
+              <a:defRPr sz="1300" b="1">
                 <a:solidFill>
-                  <a:srgbClr val="1C2330"/>
+                  <a:srgbClr val="FFFFFF"/>
                 </a:solidFill>
                 <a:latin typeface="Aptos"/>
               </a:defRPr>
             </a:pPr>
             <a:r>
-              <a:t>Usa datos ficticios y no publiques credenciales ni información personal.</a:t>
-            </a:r>
-          </a:p>
-        </p:txBody>
-      </p:sp>
-      <p:sp>
-        <p:nvSpPr>
-          <p:cNvPr id="11" name="Rounded Rectangle 10"/>
-          <p:cNvSpPr/>
-          <p:nvPr/>
-        </p:nvSpPr>
-        <p:spPr>
-          <a:xfrm>
-            <a:off x="6126479" y="1298448"/>
-            <a:ext cx="5230368" cy="4553712"/>
-          </a:xfrm>
-          <a:prstGeom prst="roundRect">
-            <a:avLst/>
-          </a:prstGeom>
-          <a:solidFill>
-            <a:srgbClr val="FFFFFF"/>
-          </a:solidFill>
-          <a:ln>
-            <a:solidFill>
-              <a:srgbClr val="E5E9EF"/>
-            </a:solidFill>
-          </a:ln>
-        </p:spPr>
-        <p:style>
-          <a:lnRef idx="1">
-            <a:schemeClr val="accent1"/>
-          </a:lnRef>
-          <a:fillRef idx="3">
-            <a:schemeClr val="accent1"/>
-          </a:fillRef>
-          <a:effectRef idx="2">
-            <a:schemeClr val="accent1"/>
-          </a:effectRef>
-          <a:fontRef idx="minor">
-            <a:schemeClr val="lt1"/>
-          </a:fontRef>
-        </p:style>
-        <p:txBody>
-          <a:bodyPr rtlCol="0" anchor="ctr"/>
-          <a:lstStyle/>
-          <a:p>
-            <a:pPr algn="ctr"/>
-          </a:p>
-        </p:txBody>
-      </p:sp>
-      <p:sp>
-        <p:nvSpPr>
-          <p:cNvPr id="12" name="Rounded Rectangle 11"/>
-          <p:cNvSpPr/>
-          <p:nvPr/>
-        </p:nvSpPr>
-        <p:spPr>
-          <a:xfrm>
-            <a:off x="6345936" y="1527048"/>
-            <a:ext cx="237744" cy="4096512"/>
-          </a:xfrm>
-          <a:prstGeom prst="roundRect">
-            <a:avLst/>
-          </a:prstGeom>
-          <a:solidFill>
-            <a:srgbClr val="C07020"/>
-          </a:solidFill>
-          <a:ln>
-            <a:noFill/>
-          </a:ln>
-        </p:spPr>
-        <p:style>
-          <a:lnRef idx="1">
-            <a:schemeClr val="accent1"/>
-          </a:lnRef>
-          <a:fillRef idx="3">
-            <a:schemeClr val="accent1"/>
-          </a:fillRef>
-          <a:effectRef idx="2">
-            <a:schemeClr val="accent1"/>
-          </a:effectRef>
-          <a:fontRef idx="minor">
-            <a:schemeClr val="lt1"/>
-          </a:fontRef>
-        </p:style>
-        <p:txBody>
-          <a:bodyPr rtlCol="0" anchor="ctr"/>
-          <a:lstStyle/>
-          <a:p>
-            <a:pPr algn="ctr"/>
-          </a:p>
-        </p:txBody>
-      </p:sp>
-      <p:sp>
-        <p:nvSpPr>
-          <p:cNvPr id="13" name="TextBox 12"/>
+              <a:t>PREGUNTA O DECISIÓN DE SALIDA</a:t>
+            </a:r>
+          </a:p>
+        </p:txBody>
+      </p:sp>
+      <p:sp>
+        <p:nvSpPr>
+          <p:cNvPr id="10" name="TextBox 9"/>
           <p:cNvSpPr txBox="1"/>
           <p:nvPr/>
         </p:nvSpPr>
         <p:spPr>
           <a:xfrm>
-            <a:off x="6784847" y="1527048"/>
-            <a:ext cx="4224528" cy="4160520"/>
+            <a:off x="932688" y="1975104"/>
+            <a:ext cx="10058400" cy="822960"/>
           </a:xfrm>
           <a:prstGeom prst="rect">
             <a:avLst/>
@@ -8233,15 +8741,51 @@
           <a:lstStyle/>
           <a:p>
             <a:pPr algn="l">
-              <a:defRPr sz="1900" b="0">
+              <a:defRPr sz="2500" b="1">
                 <a:solidFill>
-                  <a:srgbClr val="1C2330"/>
+                  <a:srgbClr val="FFFFFF"/>
                 </a:solidFill>
                 <a:latin typeface="Aptos"/>
               </a:defRPr>
             </a:pPr>
             <a:r>
-              <a:t>Si utilizas IA de forma sustantiva, registra propósito, propuesta, cambios propios y validación en el registro de IA del hito.</a:t>
+              <a:t>Completa: H1 no tendrá ____ porque ____; lo comprobaremos mediante ____. </a:t>
+            </a:r>
+          </a:p>
+        </p:txBody>
+      </p:sp>
+      <p:sp>
+        <p:nvSpPr>
+          <p:cNvPr id="11" name="TextBox 10"/>
+          <p:cNvSpPr txBox="1"/>
+          <p:nvPr/>
+        </p:nvSpPr>
+        <p:spPr>
+          <a:xfrm>
+            <a:off x="749808" y="3886200"/>
+            <a:ext cx="10607040" cy="1280160"/>
+          </a:xfrm>
+          <a:prstGeom prst="rect">
+            <a:avLst/>
+          </a:prstGeom>
+          <a:noFill/>
+        </p:spPr>
+        <p:txBody>
+          <a:bodyPr wrap="square" lIns="45720" rIns="45720" tIns="36576" bIns="36576" anchor="ctr">
+            <a:spAutoFit/>
+          </a:bodyPr>
+          <a:lstStyle/>
+          <a:p>
+            <a:pPr algn="ctr">
+              <a:defRPr sz="2300" b="1">
+                <a:solidFill>
+                  <a:srgbClr val="247E5C"/>
+                </a:solidFill>
+                <a:latin typeface="Aptos"/>
+              </a:defRPr>
+            </a:pPr>
+            <a:r>
+              <a:t>La sesión termina cuando la evidencia existe, está comprobada y puede defenderse.</a:t>
             </a:r>
           </a:p>
         </p:txBody>
@@ -8381,7 +8925,7 @@
               </a:defRPr>
             </a:pPr>
             <a:r>
-              <a:t>EXPLICAR Y DEFENDER</a:t>
+              <a:t>TRAZABILIDAD DEL CONTENIDO</a:t>
             </a:r>
           </a:p>
         </p:txBody>
@@ -8417,7 +8961,7 @@
               </a:defRPr>
             </a:pPr>
             <a:r>
-              <a:t>Cierre y defensa</a:t>
+              <a:t>Fuentes utilizadas</a:t>
             </a:r>
           </a:p>
         </p:txBody>
@@ -8503,59 +9047,14 @@
       </p:sp>
       <p:sp>
         <p:nvSpPr>
-          <p:cNvPr id="8" name="Rounded Rectangle 7"/>
-          <p:cNvSpPr/>
-          <p:nvPr/>
-        </p:nvSpPr>
-        <p:spPr>
-          <a:xfrm>
-            <a:off x="621792" y="1298448"/>
-            <a:ext cx="10927080" cy="1828800"/>
-          </a:xfrm>
-          <a:prstGeom prst="roundRect">
-            <a:avLst/>
-          </a:prstGeom>
-          <a:solidFill>
-            <a:srgbClr val="2F5BA8"/>
-          </a:solidFill>
-          <a:ln>
-            <a:solidFill>
-              <a:srgbClr val="2F5BA8"/>
-            </a:solidFill>
-          </a:ln>
-        </p:spPr>
-        <p:style>
-          <a:lnRef idx="1">
-            <a:schemeClr val="accent1"/>
-          </a:lnRef>
-          <a:fillRef idx="3">
-            <a:schemeClr val="accent1"/>
-          </a:fillRef>
-          <a:effectRef idx="2">
-            <a:schemeClr val="accent1"/>
-          </a:effectRef>
-          <a:fontRef idx="minor">
-            <a:schemeClr val="lt1"/>
-          </a:fontRef>
-        </p:style>
-        <p:txBody>
-          <a:bodyPr rtlCol="0" anchor="ctr"/>
-          <a:lstStyle/>
-          <a:p>
-            <a:pPr algn="ctr"/>
-          </a:p>
-        </p:txBody>
-      </p:sp>
-      <p:sp>
-        <p:nvSpPr>
-          <p:cNvPr id="9" name="TextBox 8"/>
+          <p:cNvPr id="8" name="TextBox 7"/>
           <p:cNvSpPr txBox="1"/>
           <p:nvPr/>
         </p:nvSpPr>
         <p:spPr>
           <a:xfrm>
-            <a:off x="932688" y="1591056"/>
-            <a:ext cx="10241280" cy="256032"/>
+            <a:off x="777240" y="1417320"/>
+            <a:ext cx="10515600" cy="658368"/>
           </a:xfrm>
           <a:prstGeom prst="rect">
             <a:avLst/>
@@ -8568,30 +9067,30 @@
           </a:bodyPr>
           <a:lstStyle/>
           <a:p>
-            <a:pPr algn="l">
-              <a:defRPr sz="1300" b="1">
+            <a:pPr algn="ctr">
+              <a:defRPr sz="2300" b="1">
                 <a:solidFill>
-                  <a:srgbClr val="FFFFFF"/>
+                  <a:srgbClr val="1C2330"/>
                 </a:solidFill>
                 <a:latin typeface="Aptos"/>
               </a:defRPr>
             </a:pPr>
             <a:r>
-              <a:t>PREGUNTA O DECISIÓN DE SALIDA</a:t>
-            </a:r>
-          </a:p>
-        </p:txBody>
-      </p:sp>
-      <p:sp>
-        <p:nvSpPr>
-          <p:cNvPr id="10" name="TextBox 9"/>
+              <a:t>Esta presentación selecciona y adapta contenido; no sustituye al libro ni copia el PDF completo.</a:t>
+            </a:r>
+          </a:p>
+        </p:txBody>
+      </p:sp>
+      <p:sp>
+        <p:nvSpPr>
+          <p:cNvPr id="9" name="TextBox 8"/>
           <p:cNvSpPr txBox="1"/>
           <p:nvPr/>
         </p:nvSpPr>
         <p:spPr>
           <a:xfrm>
-            <a:off x="932688" y="1975104"/>
-            <a:ext cx="10058400" cy="822960"/>
+            <a:off x="1005840" y="2468880"/>
+            <a:ext cx="10058400" cy="2331720"/>
           </a:xfrm>
           <a:prstGeom prst="rect">
             <a:avLst/>
@@ -8599,57 +9098,92 @@
           <a:noFill/>
         </p:spPr>
         <p:txBody>
-          <a:bodyPr wrap="square" lIns="45720" rIns="45720" tIns="36576" bIns="36576" anchor="t">
+          <a:bodyPr wrap="square" lIns="73152" rIns="45720" tIns="36576">
             <a:spAutoFit/>
           </a:bodyPr>
           <a:lstStyle/>
           <a:p>
-            <a:pPr algn="l">
-              <a:defRPr sz="2500" b="1">
+            <a:pPr>
+              <a:spcAft>
+                <a:spcPts val="900"/>
+              </a:spcAft>
+              <a:defRPr sz="2000">
                 <a:solidFill>
-                  <a:srgbClr val="FFFFFF"/>
+                  <a:srgbClr val="1C2330"/>
                 </a:solidFill>
                 <a:latin typeface="Aptos"/>
               </a:defRPr>
             </a:pPr>
             <a:r>
-              <a:t>¿Qué puedes señalar, explicar y probar al terminar este checkpoint?</a:t>
-            </a:r>
-          </a:p>
-        </p:txBody>
-      </p:sp>
-      <p:sp>
-        <p:nvSpPr>
-          <p:cNvPr id="11" name="TextBox 10"/>
-          <p:cNvSpPr txBox="1"/>
-          <p:nvPr/>
-        </p:nvSpPr>
-        <p:spPr>
-          <a:xfrm>
-            <a:off x="749808" y="3886200"/>
-            <a:ext cx="10607040" cy="1280160"/>
-          </a:xfrm>
-          <a:prstGeom prst="rect">
-            <a:avLst/>
-          </a:prstGeom>
-          <a:noFill/>
-        </p:spPr>
-        <p:txBody>
-          <a:bodyPr wrap="square" lIns="45720" rIns="45720" tIns="36576" bIns="36576" anchor="ctr">
-            <a:spAutoFit/>
-          </a:bodyPr>
-          <a:lstStyle/>
-          <a:p>
-            <a:pPr algn="ctr">
-              <a:defRPr sz="2300" b="1">
+              <a:t>•  Libro: introducción de H1 · Tema 1: objetivos de un programa</a:t>
+            </a:r>
+          </a:p>
+          <a:p>
+            <a:pPr>
+              <a:spcAft>
+                <a:spcPts val="900"/>
+              </a:spcAft>
+              <a:defRPr sz="2000">
                 <a:solidFill>
-                  <a:srgbClr val="247E5C"/>
+                  <a:srgbClr val="1C2330"/>
                 </a:solidFill>
                 <a:latin typeface="Aptos"/>
               </a:defRPr>
             </a:pPr>
             <a:r>
-              <a:t>La sesión termina cuando la evidencia existe, está comprobada y puede defenderse.</a:t>
+              <a:t>•  Fichas S206-S215 y píldoras H1</a:t>
+            </a:r>
+          </a:p>
+          <a:p>
+            <a:pPr>
+              <a:spcAft>
+                <a:spcPts val="900"/>
+              </a:spcAft>
+              <a:defRPr sz="2000">
+                <a:solidFill>
+                  <a:srgbClr val="1C2330"/>
+                </a:solidFill>
+                <a:latin typeface="Aptos"/>
+              </a:defRPr>
+            </a:pPr>
+            <a:r>
+              <a:t>•  Ejemplos revisados y adaptados a MiniJarvis; no se copian errores ni capturas antiguas del PDF.</a:t>
+            </a:r>
+          </a:p>
+        </p:txBody>
+      </p:sp>
+      <p:sp>
+        <p:nvSpPr>
+          <p:cNvPr id="10" name="TextBox 9"/>
+          <p:cNvSpPr txBox="1"/>
+          <p:nvPr/>
+        </p:nvSpPr>
+        <p:spPr>
+          <a:xfrm>
+            <a:off x="960120" y="5257800"/>
+            <a:ext cx="10241280" cy="411480"/>
+          </a:xfrm>
+          <a:prstGeom prst="rect">
+            <a:avLst/>
+          </a:prstGeom>
+          <a:noFill/>
+        </p:spPr>
+        <p:txBody>
+          <a:bodyPr wrap="square" lIns="45720" rIns="45720" tIns="36576" bIns="36576" anchor="t">
+            <a:spAutoFit/>
+          </a:bodyPr>
+          <a:lstStyle/>
+          <a:p>
+            <a:pPr algn="ctr">
+              <a:defRPr sz="1800" b="1">
+                <a:solidFill>
+                  <a:srgbClr val="2F5BA8"/>
+                </a:solidFill>
+                <a:latin typeface="Aptos"/>
+              </a:defRPr>
+            </a:pPr>
+            <a:r>
+              <a:t>Consulta el libro para ampliar, practicar y repasar errores frecuentes.</a:t>
             </a:r>
           </a:p>
         </p:txBody>

</xml_diff>

<commit_message>
feat(materiales): actualiza H1 y paquetes de distribución
Revisa las sesiones H1, añade entregables completos y sincroniza las presentaciones, el paquete Drive y el paquete Moodle. Incorpora la fase HEXA normalizada y adapta el generador a las nuevas fuentes docentes.
</commit_message>
<xml_diff>
--- a/02-PROFESORADO/03-PRESENTACIONES/POR-SESION/h1/S206-presentar-h1-y-delimitar-alcance-presentacion.pptx
+++ b/02-PROFESORADO/03-PRESENTACIONES/POR-SESION/h1/S206-presentar-h1-y-delimitar-alcance-presentacion.pptx
@@ -510,12 +510,12 @@
           <a:lstStyle/>
           <a:p>
             <a:r>
-              <a:t>Objetivo docente: Entender el reto, delimitar H1 y convertirlo en requisitos observables.</a:t>
-            </a:r>
-          </a:p>
-          <a:p>
-            <a:r>
-              <a:t>Diapositiva 1 de 9: H1: qué vamos a construir y qué queda fuera</a:t>
+              <a:t>Objetivo docente: Al terminar, debes entender qué es H1, qué entra, qué no entra y cómo se demostrará el avance.</a:t>
+            </a:r>
+          </a:p>
+          <a:p>
+            <a:r>
+              <a:t>Diapositiva 1 de 9: Qué vas a aprender</a:t>
             </a:r>
           </a:p>
           <a:p>
@@ -525,7 +525,7 @@
           </a:p>
           <a:p>
             <a:r>
-              <a:t>Presenta el producto y anticipa la evidencia: Quede una evidencia y siguiente paso registrados.</a:t>
+              <a:t>Presenta el producto y anticipa la evidencia: Conserva una decisión de alcance fechada como S206 que incluya:</a:t>
             </a:r>
           </a:p>
           <a:p>
@@ -535,32 +535,7 @@
           </a:p>
           <a:p>
             <a:r>
-              <a:t>- 00:00–00:04 / D1: ACTIVAR: Presenta H1 como primer incremento técnico. No muestres código todavía. Pregunta qué creen que debería poder hacer al final del hito.</a:t>
-            </a:r>
-          </a:p>
-          <a:p>
-            <a:r>
-              <a:t>- 00:04–00:09 / D2: ACTIVAR: Lee la salida y pregunta qué partes parecen fijas y cuál depende de la entrada.</a:t>
-            </a:r>
-          </a:p>
-          <a:p>
-            <a:r>
-              <a:t>- 00:09–00:15 / D3: PÍLDORA DOCENTE 1/1: Explica los tres objetivos que aparecen en Tema 1 y tradúcelos al nivel de H1. Evita tecnicismos de rendimiento.</a:t>
-            </a:r>
-          </a:p>
-          <a:p>
-            <a:r>
-              <a:t>- 00:15–00:25 / D4: ACTIVIDAD: Lee propuestas y obliga a justificar. No des la clasificación de inmediato.</a:t>
-            </a:r>
-          </a:p>
-          <a:p>
-            <a:r>
-              <a:t>- 00:25–00:38 / D5: ACTIVIDAD: Modela un requisito: “Al ejecutar, aparece un saludo”. Luego circula sin dictar el resto.</a:t>
-            </a:r>
-          </a:p>
-          <a:p>
-            <a:r>
-              <a:t>- 00:38–00:45 / D6: CIERRE: Escucha 2–3 microdefensas y pide registrar objetivo, decisión y siguiente paso.</a:t>
+              <a:t>- 45 minutos: Clasificad estas ideas en tres columnas: entra en H1, más adelante, fuera del reto. Usad criterio, no gusto personal.</a:t>
             </a:r>
           </a:p>
           <a:p>
@@ -570,7 +545,57 @@
           </a:p>
           <a:p>
             <a:r>
-              <a:t>- PÍLDORA DOCENTE 1/1: Explica los tres objetivos que aparecen en Tema 1 y tradúcelos al nivel de H1. Evita tecnicismos de rendimiento.</a:t>
+              <a:t>- Úsala ahora, antes de que clasifiquen qué entra y qué queda fuera.</a:t>
+            </a:r>
+          </a:p>
+          <a:p>
+            <a:r>
+              <a:t>- Un primer programa debe ser correcto, eficiente y mantenible. Correcto significa que hace lo pedido y podemos comprobarlo. Eficiente, en H1, no significa que vaya rapidísimo: significa que no añade complejidad innecesaria. Mantenible significa que se entiende y se puede modificar sin romperlo fácilmente.</a:t>
+            </a:r>
+          </a:p>
+          <a:p>
+            <a:r>
+              <a:t>- Ejemplo para proyectar:</a:t>
+            </a:r>
+          </a:p>
+          <a:p>
+            <a:r>
+              <a:t>- final String NOMBRE_ASISTENTE = "MiniJarvis";</a:t>
+            </a:r>
+          </a:p>
+          <a:p>
+            <a:r>
+              <a:t>- String nombreUsuario = "Laura";</a:t>
+            </a:r>
+          </a:p>
+          <a:p>
+            <a:r>
+              <a:t>- System.out.println("Hola, soy " + NOMBRE_ASISTENTE + ".");</a:t>
+            </a:r>
+          </a:p>
+          <a:p>
+            <a:r>
+              <a:t>- System.out.println("Encantado, " + nombreUsuario + ".");</a:t>
+            </a:r>
+          </a:p>
+          <a:p>
+            <a:r>
+              <a:t>- Pregunta al alumnado:</a:t>
+            </a:r>
+          </a:p>
+          <a:p>
+            <a:r>
+              <a:t>- Qué requisito demuestra cada línea visible, qué parte quitarías si no pertenece a H1 y qué nombre ayuda a entender el código.</a:t>
+            </a:r>
+          </a:p>
+          <a:p>
+            <a:r>
+              <a:t>- Error frecuente que debes cortar:</a:t>
+            </a:r>
+          </a:p>
+          <a:p>
+            <a:r>
+              <a:t>- Compilar no basta para decir que es correcto. Falta comprobar comportamiento.</a:t>
             </a:r>
           </a:p>
           <a:p>
@@ -645,7 +670,7 @@
           <a:lstStyle/>
           <a:p>
             <a:r>
-              <a:t>Objetivo docente: Entender el reto, delimitar H1 y convertirlo en requisitos observables.</a:t>
+              <a:t>Objetivo docente: Al terminar, debes entender qué es H1, qué entra, qué no entra y cómo se demostrará el avance.</a:t>
             </a:r>
           </a:p>
           <a:p>
@@ -660,12 +685,12 @@
           </a:p>
           <a:p>
             <a:r>
-              <a:t>- Objetivo: Entender el reto, delimitar H1 y convertirlo en requisitos observables.</a:t>
-            </a:r>
-          </a:p>
-          <a:p>
-            <a:r>
-              <a:t>- Comprobación: Quede una evidencia y siguiente paso registrados.</a:t>
+              <a:t>- Objetivo: Al terminar, debes entender qué es H1, qué entra, qué no entra y cómo se demostrará el avance.</a:t>
+            </a:r>
+          </a:p>
+          <a:p>
+            <a:r>
+              <a:t>- Comprobación: Conserva una decisión de alcance fechada como S206 que incluya:</a:t>
             </a:r>
           </a:p>
           <a:p>
@@ -740,7 +765,7 @@
           <a:lstStyle/>
           <a:p>
             <a:r>
-              <a:t>Objetivo docente: Entender el reto, delimitar H1 y convertirlo en requisitos observables.</a:t>
+              <a:t>Objetivo docente: Al terminar, debes entender qué es H1, qué entra, qué no entra y cómo se demostrará el avance.</a:t>
             </a:r>
           </a:p>
           <a:p>
@@ -845,7 +870,7 @@
           <a:lstStyle/>
           <a:p>
             <a:r>
-              <a:t>Objetivo docente: Entender el reto, delimitar H1 y convertirlo en requisitos observables.</a:t>
+              <a:t>Objetivo docente: Al terminar, debes entender qué es H1, qué entra, qué no entra y cómo se demostrará el avance.</a:t>
             </a:r>
           </a:p>
           <a:p>
@@ -960,12 +985,12 @@
           <a:lstStyle/>
           <a:p>
             <a:r>
-              <a:t>Objetivo docente: Entender el reto, delimitar H1 y convertirlo en requisitos observables.</a:t>
-            </a:r>
-          </a:p>
-          <a:p>
-            <a:r>
-              <a:t>Diapositiva 5 de 9: De una idea a requisitos comprobables</a:t>
+              <a:t>Objetivo docente: Al terminar, debes entender qué es H1, qué entra, qué no entra y cómo se demostrará el avance.</a:t>
+            </a:r>
+          </a:p>
+          <a:p>
+            <a:r>
+              <a:t>Diapositiva 5 de 9: Correcto, eficiente y mantenible</a:t>
             </a:r>
           </a:p>
           <a:p>
@@ -990,12 +1015,17 @@
           </a:p>
           <a:p>
             <a:r>
-              <a:t>- Sencillo: no añade trabajo o complejidad innecesaria.</a:t>
+              <a:t>- Eficiente para esta escala: evita trabajo y complejidad innecesarios.</a:t>
             </a:r>
           </a:p>
           <a:p>
             <a:r>
               <a:t>- Mantenible: se entiende y puede modificarse sin romperse.</a:t>
+            </a:r>
+          </a:p>
+          <a:p>
+            <a:r>
+              <a:t>- La sencillez ayuda a la eficiencia y al mantenimiento; no sustituye a ninguno.</a:t>
             </a:r>
           </a:p>
           <a:p>
@@ -1070,7 +1100,7 @@
           <a:lstStyle/>
           <a:p>
             <a:r>
-              <a:t>Objetivo docente: Entender el reto, delimitar H1 y convertirlo en requisitos observables.</a:t>
+              <a:t>Objetivo docente: Al terminar, debes entender qué es H1, qué entra, qué no entra y cómo se demostrará el avance.</a:t>
             </a:r>
           </a:p>
           <a:p>
@@ -1180,7 +1210,7 @@
           <a:lstStyle/>
           <a:p>
             <a:r>
-              <a:t>Objetivo docente: Entender el reto, delimitar H1 y convertirlo en requisitos observables.</a:t>
+              <a:t>Objetivo docente: Al terminar, debes entender qué es H1, qué entra, qué no entra y cómo se demostrará el avance.</a:t>
             </a:r>
           </a:p>
           <a:p>
@@ -1195,7 +1225,7 @@
           </a:p>
           <a:p>
             <a:r>
-              <a:t>Comprueba la evidencia en su fuente canónica: Quede una evidencia y siguiente paso registrados.</a:t>
+              <a:t>Comprueba la evidencia en su fuente canónica: Conserva una decisión de alcance fechada como S206 que incluya:</a:t>
             </a:r>
           </a:p>
           <a:p>
@@ -1290,7 +1320,7 @@
           <a:lstStyle/>
           <a:p>
             <a:r>
-              <a:t>Objetivo docente: Entender el reto, delimitar H1 y convertirlo en requisitos observables.</a:t>
+              <a:t>Objetivo docente: Al terminar, debes entender qué es H1, qué entra, qué no entra y cómo se demostrará el avance.</a:t>
             </a:r>
           </a:p>
           <a:p>
@@ -1385,12 +1415,12 @@
           <a:lstStyle/>
           <a:p>
             <a:r>
-              <a:t>Objetivo docente: Entender el reto, delimitar H1 y convertirlo en requisitos observables.</a:t>
-            </a:r>
-          </a:p>
-          <a:p>
-            <a:r>
-              <a:t>Diapositiva 9 de 9: Fuentes utilizadas</a:t>
+              <a:t>Objetivo docente: Al terminar, debes entender qué es H1, qué entra, qué no entra y cómo se demostrará el avance.</a:t>
+            </a:r>
+          </a:p>
+          <a:p>
+            <a:r>
+              <a:t>Diapositiva 9 de 9: Fuentes diferenciadas</a:t>
             </a:r>
           </a:p>
           <a:p>
@@ -1405,17 +1435,17 @@
           </a:p>
           <a:p>
             <a:r>
-              <a:t>- Libro: introducción de H1 · Tema 1: objetivos de un programa</a:t>
-            </a:r>
-          </a:p>
-          <a:p>
-            <a:r>
-              <a:t>- Fichas S206-S215 y píldoras H1</a:t>
-            </a:r>
-          </a:p>
-          <a:p>
-            <a:r>
-              <a:t>- Ejemplos revisados y adaptados a MiniJarvis; no se copian errores ni capturas antiguas del PDF.</a:t>
+              <a:t>- Libro por hitos · Capítulo 00: hitos y evidencias</a:t>
+            </a:r>
+          </a:p>
+          <a:p>
+            <a:r>
+              <a:t>- PDF Tema 1 · §2: objetivos de la programación</a:t>
+            </a:r>
+          </a:p>
+          <a:p>
+            <a:r>
+              <a:t>- Proyecto MiniJarvis · fichas S206-S215, píldoras H1 y criterios de evidencia</a:t>
             </a:r>
           </a:p>
           <a:p>
@@ -4624,7 +4654,7 @@
               </a:defRPr>
             </a:pPr>
             <a:r>
-              <a:t>H1: qué vamos a construir y qué queda fuera</a:t>
+              <a:t>Qué vas a aprender</a:t>
             </a:r>
           </a:p>
         </p:txBody>
@@ -4660,7 +4690,7 @@
               </a:defRPr>
             </a:pPr>
             <a:r>
-              <a:t>H1 — Primer MiniJarvis</a:t>
+              <a:t>H1 — Primer asistente ejecutable</a:t>
             </a:r>
           </a:p>
         </p:txBody>
@@ -4704,42 +4734,6 @@
       <p:sp>
         <p:nvSpPr>
           <p:cNvPr id="9" name="TextBox 8"/>
-          <p:cNvSpPr txBox="1"/>
-          <p:nvPr/>
-        </p:nvSpPr>
-        <p:spPr>
-          <a:xfrm>
-            <a:off x="713232" y="4965192"/>
-            <a:ext cx="10241280" cy="594360"/>
-          </a:xfrm>
-          <a:prstGeom prst="rect">
-            <a:avLst/>
-          </a:prstGeom>
-          <a:noFill/>
-        </p:spPr>
-        <p:txBody>
-          <a:bodyPr wrap="square" lIns="45720" rIns="45720" tIns="36576" bIns="36576" anchor="t">
-            <a:spAutoFit/>
-          </a:bodyPr>
-          <a:lstStyle/>
-          <a:p>
-            <a:pPr algn="l">
-              <a:defRPr sz="1700" b="0">
-                <a:solidFill>
-                  <a:srgbClr val="D2D9E4"/>
-                </a:solidFill>
-                <a:latin typeface="Aptos"/>
-              </a:defRPr>
-            </a:pPr>
-            <a:r>
-              <a:t>Individual con contraste por parejas o equipo cuando la práctica lo requiera</a:t>
-            </a:r>
-          </a:p>
-        </p:txBody>
-      </p:sp>
-      <p:sp>
-        <p:nvSpPr>
-          <p:cNvPr id="10" name="TextBox 9"/>
           <p:cNvSpPr txBox="1"/>
           <p:nvPr/>
         </p:nvSpPr>
@@ -5023,7 +5017,7 @@
               </a:defRPr>
             </a:pPr>
             <a:r>
-              <a:t>MiniJarvis · 1.º DAW · Sesión 206 · H1 — Primer MiniJarvis</a:t>
+              <a:t>MiniJarvis · 1.º DAW · Sesión 206 · H1 — Primer asistente ejecutable</a:t>
             </a:r>
           </a:p>
         </p:txBody>
@@ -5104,7 +5098,7 @@
               </a:defRPr>
             </a:pPr>
             <a:r>
-              <a:t>Objetivo: Entender el reto, delimitar H1 y convertirlo en requisitos observables.</a:t>
+              <a:t>Objetivo: Al terminar, debes entender qué es H1, qué entra, qué no entra y cómo se demostrará el avance.</a:t>
             </a:r>
           </a:p>
         </p:txBody>
@@ -5185,7 +5179,7 @@
               </a:defRPr>
             </a:pPr>
             <a:r>
-              <a:t>Comprobación: Quede una evidencia y siguiente paso registrados.</a:t>
+              <a:t>Comprobación: Conserva una decisión de alcance fechada como S206 que incluya:</a:t>
             </a:r>
           </a:p>
         </p:txBody>
@@ -5440,7 +5434,7 @@
               </a:defRPr>
             </a:pPr>
             <a:r>
-              <a:t>MiniJarvis · 1.º DAW · Sesión 206 · H1 — Primer MiniJarvis</a:t>
+              <a:t>MiniJarvis · 1.º DAW · Sesión 206 · H1 — Primer asistente ejecutable</a:t>
             </a:r>
           </a:p>
         </p:txBody>
@@ -6100,7 +6094,7 @@
               </a:defRPr>
             </a:pPr>
             <a:r>
-              <a:t>MiniJarvis · 1.º DAW · Sesión 206 · H1 — Primer MiniJarvis</a:t>
+              <a:t>MiniJarvis · 1.º DAW · Sesión 206 · H1 — Primer asistente ejecutable</a:t>
             </a:r>
           </a:p>
         </p:txBody>
@@ -6528,7 +6522,7 @@
               </a:defRPr>
             </a:pPr>
             <a:r>
-              <a:t>De una idea a requisitos comprobables</a:t>
+              <a:t>Correcto, eficiente y mantenible</a:t>
             </a:r>
           </a:p>
         </p:txBody>
@@ -6607,7 +6601,7 @@
               </a:defRPr>
             </a:pPr>
             <a:r>
-              <a:t>MiniJarvis · 1.º DAW · Sesión 206 · H1 — Primer MiniJarvis</a:t>
+              <a:t>MiniJarvis · 1.º DAW · Sesión 206 · H1 — Primer asistente ejecutable</a:t>
             </a:r>
           </a:p>
         </p:txBody>
@@ -6621,7 +6615,7 @@
         <p:spPr>
           <a:xfrm>
             <a:off x="566928" y="1261872"/>
-            <a:ext cx="5212080" cy="2199132"/>
+            <a:ext cx="3398520" cy="2199132"/>
           </a:xfrm>
           <a:prstGeom prst="roundRect">
             <a:avLst/>
@@ -6702,7 +6696,7 @@
         <p:spPr>
           <a:xfrm>
             <a:off x="1225295" y="1426463"/>
-            <a:ext cx="4434840" cy="1961388"/>
+            <a:ext cx="2621280" cy="1961388"/>
           </a:xfrm>
           <a:prstGeom prst="rect">
             <a:avLst/>
@@ -6716,7 +6710,7 @@
           <a:lstStyle/>
           <a:p>
             <a:pPr algn="l">
-              <a:defRPr sz="1800" b="0">
+              <a:defRPr sz="1500" b="0">
                 <a:solidFill>
                   <a:srgbClr val="1C2330"/>
                 </a:solidFill>
@@ -6737,8 +6731,8 @@
         </p:nvSpPr>
         <p:spPr>
           <a:xfrm>
-            <a:off x="6007608" y="1261872"/>
-            <a:ext cx="5212080" cy="2199132"/>
+            <a:off x="4194048" y="1261872"/>
+            <a:ext cx="3398520" cy="2199132"/>
           </a:xfrm>
           <a:prstGeom prst="roundRect">
             <a:avLst/>
@@ -6782,7 +6776,7 @@
         </p:nvSpPr>
         <p:spPr>
           <a:xfrm>
-            <a:off x="6208776" y="1426463"/>
+            <a:off x="4395216" y="1426463"/>
             <a:ext cx="384048" cy="347472"/>
           </a:xfrm>
           <a:prstGeom prst="rect">
@@ -6818,8 +6812,8 @@
         </p:nvSpPr>
         <p:spPr>
           <a:xfrm>
-            <a:off x="6665976" y="1426463"/>
-            <a:ext cx="4434840" cy="1961388"/>
+            <a:off x="4852416" y="1426463"/>
+            <a:ext cx="2621280" cy="1961388"/>
           </a:xfrm>
           <a:prstGeom prst="rect">
             <a:avLst/>
@@ -6833,7 +6827,7 @@
           <a:lstStyle/>
           <a:p>
             <a:pPr algn="l">
-              <a:defRPr sz="1800" b="0">
+              <a:defRPr sz="1500" b="0">
                 <a:solidFill>
                   <a:srgbClr val="1C2330"/>
                 </a:solidFill>
@@ -6854,8 +6848,8 @@
         </p:nvSpPr>
         <p:spPr>
           <a:xfrm>
-            <a:off x="566928" y="3662172"/>
-            <a:ext cx="5212080" cy="2199132"/>
+            <a:off x="7821167" y="1261872"/>
+            <a:ext cx="3398520" cy="2199132"/>
           </a:xfrm>
           <a:prstGeom prst="roundRect">
             <a:avLst/>
@@ -6899,7 +6893,7 @@
         </p:nvSpPr>
         <p:spPr>
           <a:xfrm>
-            <a:off x="768096" y="3826763"/>
+            <a:off x="8022336" y="1426463"/>
             <a:ext cx="384048" cy="347472"/>
           </a:xfrm>
           <a:prstGeom prst="rect">
@@ -6935,8 +6929,8 @@
         </p:nvSpPr>
         <p:spPr>
           <a:xfrm>
-            <a:off x="1225295" y="3826763"/>
-            <a:ext cx="4434840" cy="1961388"/>
+            <a:off x="8479536" y="1426463"/>
+            <a:ext cx="2621280" cy="1961388"/>
           </a:xfrm>
           <a:prstGeom prst="rect">
             <a:avLst/>
@@ -6950,7 +6944,7 @@
           <a:lstStyle/>
           <a:p>
             <a:pPr algn="l">
-              <a:defRPr sz="1800" b="0">
+              <a:defRPr sz="1500" b="0">
                 <a:solidFill>
                   <a:srgbClr val="1C2330"/>
                 </a:solidFill>
@@ -6958,7 +6952,7 @@
               </a:defRPr>
             </a:pPr>
             <a:r>
-              <a:t>Sencillo: no añade trabajo o complejidad innecesaria.</a:t>
+              <a:t>Eficiente para esta escala: evita trabajo y complejidad innecesarios.</a:t>
             </a:r>
           </a:p>
         </p:txBody>
@@ -6971,8 +6965,8 @@
         </p:nvSpPr>
         <p:spPr>
           <a:xfrm>
-            <a:off x="6007608" y="3662172"/>
-            <a:ext cx="5212080" cy="2199132"/>
+            <a:off x="566928" y="3662172"/>
+            <a:ext cx="3398520" cy="2199132"/>
           </a:xfrm>
           <a:prstGeom prst="roundRect">
             <a:avLst/>
@@ -7016,7 +7010,7 @@
         </p:nvSpPr>
         <p:spPr>
           <a:xfrm>
-            <a:off x="6208776" y="3826763"/>
+            <a:off x="768096" y="3826763"/>
             <a:ext cx="384048" cy="347472"/>
           </a:xfrm>
           <a:prstGeom prst="rect">
@@ -7052,8 +7046,8 @@
         </p:nvSpPr>
         <p:spPr>
           <a:xfrm>
-            <a:off x="6665976" y="3826763"/>
-            <a:ext cx="4434840" cy="1961388"/>
+            <a:off x="1225295" y="3826763"/>
+            <a:ext cx="2621280" cy="1961388"/>
           </a:xfrm>
           <a:prstGeom prst="rect">
             <a:avLst/>
@@ -7067,7 +7061,7 @@
           <a:lstStyle/>
           <a:p>
             <a:pPr algn="l">
-              <a:defRPr sz="1800" b="0">
+              <a:defRPr sz="1500" b="0">
                 <a:solidFill>
                   <a:srgbClr val="1C2330"/>
                 </a:solidFill>
@@ -7076,6 +7070,123 @@
             </a:pPr>
             <a:r>
               <a:t>Mantenible: se entiende y puede modificarse sin romperse.</a:t>
+            </a:r>
+          </a:p>
+        </p:txBody>
+      </p:sp>
+      <p:sp>
+        <p:nvSpPr>
+          <p:cNvPr id="20" name="Rounded Rectangle 19"/>
+          <p:cNvSpPr/>
+          <p:nvPr/>
+        </p:nvSpPr>
+        <p:spPr>
+          <a:xfrm>
+            <a:off x="4194048" y="3662172"/>
+            <a:ext cx="3398520" cy="2199132"/>
+          </a:xfrm>
+          <a:prstGeom prst="roundRect">
+            <a:avLst/>
+          </a:prstGeom>
+          <a:solidFill>
+            <a:srgbClr val="FFFFFF"/>
+          </a:solidFill>
+          <a:ln>
+            <a:solidFill>
+              <a:srgbClr val="E5E9EF"/>
+            </a:solidFill>
+          </a:ln>
+        </p:spPr>
+        <p:style>
+          <a:lnRef idx="1">
+            <a:schemeClr val="accent1"/>
+          </a:lnRef>
+          <a:fillRef idx="3">
+            <a:schemeClr val="accent1"/>
+          </a:fillRef>
+          <a:effectRef idx="2">
+            <a:schemeClr val="accent1"/>
+          </a:effectRef>
+          <a:fontRef idx="minor">
+            <a:schemeClr val="lt1"/>
+          </a:fontRef>
+        </p:style>
+        <p:txBody>
+          <a:bodyPr rtlCol="0" anchor="ctr"/>
+          <a:lstStyle/>
+          <a:p>
+            <a:pPr algn="ctr"/>
+          </a:p>
+        </p:txBody>
+      </p:sp>
+      <p:sp>
+        <p:nvSpPr>
+          <p:cNvPr id="21" name="TextBox 20"/>
+          <p:cNvSpPr txBox="1"/>
+          <p:nvPr/>
+        </p:nvSpPr>
+        <p:spPr>
+          <a:xfrm>
+            <a:off x="4395216" y="3826763"/>
+            <a:ext cx="384048" cy="347472"/>
+          </a:xfrm>
+          <a:prstGeom prst="rect">
+            <a:avLst/>
+          </a:prstGeom>
+          <a:noFill/>
+        </p:spPr>
+        <p:txBody>
+          <a:bodyPr wrap="square" lIns="45720" rIns="45720" tIns="36576" bIns="36576" anchor="t">
+            <a:spAutoFit/>
+          </a:bodyPr>
+          <a:lstStyle/>
+          <a:p>
+            <a:pPr algn="l">
+              <a:defRPr sz="1500" b="1">
+                <a:solidFill>
+                  <a:srgbClr val="2F5BA8"/>
+                </a:solidFill>
+                <a:latin typeface="Aptos"/>
+              </a:defRPr>
+            </a:pPr>
+            <a:r>
+              <a:t>05</a:t>
+            </a:r>
+          </a:p>
+        </p:txBody>
+      </p:sp>
+      <p:sp>
+        <p:nvSpPr>
+          <p:cNvPr id="22" name="TextBox 21"/>
+          <p:cNvSpPr txBox="1"/>
+          <p:nvPr/>
+        </p:nvSpPr>
+        <p:spPr>
+          <a:xfrm>
+            <a:off x="4852416" y="3826763"/>
+            <a:ext cx="2621280" cy="1961388"/>
+          </a:xfrm>
+          <a:prstGeom prst="rect">
+            <a:avLst/>
+          </a:prstGeom>
+          <a:noFill/>
+        </p:spPr>
+        <p:txBody>
+          <a:bodyPr wrap="square" lIns="45720" rIns="45720" tIns="36576" bIns="36576" anchor="t">
+            <a:spAutoFit/>
+          </a:bodyPr>
+          <a:lstStyle/>
+          <a:p>
+            <a:pPr algn="l">
+              <a:defRPr sz="1500" b="0">
+                <a:solidFill>
+                  <a:srgbClr val="1C2330"/>
+                </a:solidFill>
+                <a:latin typeface="Aptos"/>
+              </a:defRPr>
+            </a:pPr>
+            <a:r>
+              <a:t>La sencillez ayuda a la eficiencia y al mantenimiento; no sustituye a ninguno.</a:t>
             </a:r>
           </a:p>
         </p:txBody>
@@ -7330,7 +7441,7 @@
               </a:defRPr>
             </a:pPr>
             <a:r>
-              <a:t>MiniJarvis · 1.º DAW · Sesión 206 · H1 — Primer MiniJarvis</a:t>
+              <a:t>MiniJarvis · 1.º DAW · Sesión 206 · H1 — Primer asistente ejecutable</a:t>
             </a:r>
           </a:p>
         </p:txBody>
@@ -8053,7 +8164,7 @@
               </a:defRPr>
             </a:pPr>
             <a:r>
-              <a:t>MiniJarvis · 1.º DAW · Sesión 206 · H1 — Primer MiniJarvis</a:t>
+              <a:t>MiniJarvis · 1.º DAW · Sesión 206 · H1 — Primer asistente ejecutable</a:t>
             </a:r>
           </a:p>
         </p:txBody>
@@ -8632,7 +8743,7 @@
               </a:defRPr>
             </a:pPr>
             <a:r>
-              <a:t>MiniJarvis · 1.º DAW · Sesión 206 · H1 — Primer MiniJarvis</a:t>
+              <a:t>MiniJarvis · 1.º DAW · Sesión 206 · H1 — Primer asistente ejecutable</a:t>
             </a:r>
           </a:p>
         </p:txBody>
@@ -8961,7 +9072,7 @@
               </a:defRPr>
             </a:pPr>
             <a:r>
-              <a:t>Fuentes utilizadas</a:t>
+              <a:t>Fuentes diferenciadas</a:t>
             </a:r>
           </a:p>
         </p:txBody>
@@ -9040,7 +9151,7 @@
               </a:defRPr>
             </a:pPr>
             <a:r>
-              <a:t>MiniJarvis · 1.º DAW · Sesión 206 · H1 — Primer MiniJarvis</a:t>
+              <a:t>MiniJarvis · 1.º DAW · Sesión 206 · H1 — Primer asistente ejecutable</a:t>
             </a:r>
           </a:p>
         </p:txBody>
@@ -9115,7 +9226,7 @@
               </a:defRPr>
             </a:pPr>
             <a:r>
-              <a:t>•  Libro: introducción de H1 · Tema 1: objetivos de un programa</a:t>
+              <a:t>•  Libro por hitos · Capítulo 00: hitos y evidencias</a:t>
             </a:r>
           </a:p>
           <a:p>
@@ -9131,7 +9242,7 @@
               </a:defRPr>
             </a:pPr>
             <a:r>
-              <a:t>•  Fichas S206-S215 y píldoras H1</a:t>
+              <a:t>•  PDF Tema 1 · §2: objetivos de la programación</a:t>
             </a:r>
           </a:p>
           <a:p>
@@ -9147,7 +9258,7 @@
               </a:defRPr>
             </a:pPr>
             <a:r>
-              <a:t>•  Ejemplos revisados y adaptados a MiniJarvis; no se copian errores ni capturas antiguas del PDF.</a:t>
+              <a:t>•  Proyecto MiniJarvis · fichas S206-S215, píldoras H1 y criterios de evidencia</a:t>
             </a:r>
           </a:p>
         </p:txBody>

</xml_diff>